<commit_message>
docs(appchain): reconcile capabilities and open work
</commit_message>
<xml_diff>
--- a/docs/YANO_APP_CHAIN_OVERVIEW.pptx
+++ b/docs/YANO_APP_CHAIN_OVERVIEW.pptx
@@ -2,25 +2,25 @@
 <file path=ppt/presentation.xml><?xml version="1.0" encoding="utf-8"?>
 <p:presentation xmlns:p="http://schemas.openxmlformats.org/presentationml/2006/main">
   <p:sldMasterIdLst>
-    <p:sldMasterId xmlns:r="http://schemas.openxmlformats.org/officeDocument/2006/relationships" id="2147483648" r:id="Ref0e94d4fb134b3a"/>
+    <p:sldMasterId xmlns:r="http://schemas.openxmlformats.org/officeDocument/2006/relationships" id="2147483648" r:id="Rebad1624c79746e2"/>
   </p:sldMasterIdLst>
   <p:notesMasterIdLst>
-    <p:notesMasterId xmlns:r="http://schemas.openxmlformats.org/officeDocument/2006/relationships" r:id="Rde873ff7a83b44cc"/>
+    <p:notesMasterId xmlns:r="http://schemas.openxmlformats.org/officeDocument/2006/relationships" r:id="R8c80c2260826417e"/>
   </p:notesMasterIdLst>
   <p:sldIdLst>
-    <p:sldId xmlns:r="http://schemas.openxmlformats.org/officeDocument/2006/relationships" id="256" r:id="R5ee8ecd474e84000"/>
-    <p:sldId xmlns:r="http://schemas.openxmlformats.org/officeDocument/2006/relationships" id="257" r:id="R25e7bc387a2f4fc1"/>
-    <p:sldId xmlns:r="http://schemas.openxmlformats.org/officeDocument/2006/relationships" id="258" r:id="Rfda31ccd2b2d4813"/>
-    <p:sldId xmlns:r="http://schemas.openxmlformats.org/officeDocument/2006/relationships" id="259" r:id="Rcf4d8f0c549146a1"/>
-    <p:sldId xmlns:r="http://schemas.openxmlformats.org/officeDocument/2006/relationships" id="260" r:id="R48eaae71b5bb4ab4"/>
-    <p:sldId xmlns:r="http://schemas.openxmlformats.org/officeDocument/2006/relationships" id="261" r:id="R278976a8cc174d27"/>
-    <p:sldId xmlns:r="http://schemas.openxmlformats.org/officeDocument/2006/relationships" id="262" r:id="Ree21004586b3467a"/>
-    <p:sldId xmlns:r="http://schemas.openxmlformats.org/officeDocument/2006/relationships" id="263" r:id="R90a9574d73eb4b9a"/>
-    <p:sldId xmlns:r="http://schemas.openxmlformats.org/officeDocument/2006/relationships" id="264" r:id="R49237f21d5944359"/>
-    <p:sldId xmlns:r="http://schemas.openxmlformats.org/officeDocument/2006/relationships" id="265" r:id="R792284b0008a4a2c"/>
-    <p:sldId xmlns:r="http://schemas.openxmlformats.org/officeDocument/2006/relationships" id="266" r:id="Rea1c0f7a6c7b4def"/>
-    <p:sldId xmlns:r="http://schemas.openxmlformats.org/officeDocument/2006/relationships" id="267" r:id="R75335365d6594ede"/>
-    <p:sldId xmlns:r="http://schemas.openxmlformats.org/officeDocument/2006/relationships" id="268" r:id="Rb290eb6fbe2144a8"/>
+    <p:sldId xmlns:r="http://schemas.openxmlformats.org/officeDocument/2006/relationships" id="256" r:id="R231e7696f0a844f8"/>
+    <p:sldId xmlns:r="http://schemas.openxmlformats.org/officeDocument/2006/relationships" id="257" r:id="R1447aea5ec774c9e"/>
+    <p:sldId xmlns:r="http://schemas.openxmlformats.org/officeDocument/2006/relationships" id="258" r:id="R2f4eac101469430b"/>
+    <p:sldId xmlns:r="http://schemas.openxmlformats.org/officeDocument/2006/relationships" id="259" r:id="R1ee8035477dd478f"/>
+    <p:sldId xmlns:r="http://schemas.openxmlformats.org/officeDocument/2006/relationships" id="260" r:id="R489073af23cc484c"/>
+    <p:sldId xmlns:r="http://schemas.openxmlformats.org/officeDocument/2006/relationships" id="261" r:id="R1a652b1c1c414401"/>
+    <p:sldId xmlns:r="http://schemas.openxmlformats.org/officeDocument/2006/relationships" id="262" r:id="R7f0d3ae9d1d54d84"/>
+    <p:sldId xmlns:r="http://schemas.openxmlformats.org/officeDocument/2006/relationships" id="263" r:id="R60c49dddbcbf4c56"/>
+    <p:sldId xmlns:r="http://schemas.openxmlformats.org/officeDocument/2006/relationships" id="264" r:id="R4414a3c4c9ca449e"/>
+    <p:sldId xmlns:r="http://schemas.openxmlformats.org/officeDocument/2006/relationships" id="265" r:id="Rf9c5961a683e407f"/>
+    <p:sldId xmlns:r="http://schemas.openxmlformats.org/officeDocument/2006/relationships" id="266" r:id="R9ff9908a52554527"/>
+    <p:sldId xmlns:r="http://schemas.openxmlformats.org/officeDocument/2006/relationships" id="267" r:id="R2decb7b753254e89"/>
+    <p:sldId xmlns:r="http://schemas.openxmlformats.org/officeDocument/2006/relationships" id="268" r:id="Ra734b993fd054875"/>
   </p:sldIdLst>
   <p:sldSz cx="12192000" cy="6858000"/>
   <p:notesSz cx="6858000" cy="9144000"/>
@@ -1405,7 +1405,7 @@
   </p:cSld>
   <p:clrMap bg1="lt1" tx1="dk1" bg2="lt2" tx2="dk2" accent1="accent1" accent2="accent2" accent3="accent3" accent4="accent4" accent5="accent5" accent6="accent6" hlink="hlink" folHlink="folHlink"/>
   <p:sldLayoutIdLst>
-    <p:sldLayoutId xmlns:r="http://schemas.openxmlformats.org/officeDocument/2006/relationships" id="2147483649" r:id="Rb214ac8328764a66"/>
+    <p:sldLayoutId xmlns:r="http://schemas.openxmlformats.org/officeDocument/2006/relationships" id="2147483649" r:id="R759525f300be448e"/>
   </p:sldLayoutIdLst>
   <p:txStyles>
     <p:titleStyle>
@@ -2019,6 +2019,7 @@
           <a:lstStyle xmlns:a="http://schemas.openxmlformats.org/drawingml/2006/main"/>
           <a:p xmlns:a="http://schemas.openxmlformats.org/drawingml/2006/main">
             <a:pPr algn="l">
+              <a:buNone/>
               <a:defRPr sz="1200" b="1">
                 <a:solidFill>
                   <a:srgbClr val="3D8DFF"/>
@@ -2077,6 +2078,7 @@
           <a:lstStyle xmlns:a="http://schemas.openxmlformats.org/drawingml/2006/main"/>
           <a:p xmlns:a="http://schemas.openxmlformats.org/drawingml/2006/main">
             <a:pPr algn="l">
+              <a:buNone/>
               <a:defRPr sz="4350" b="1">
                 <a:solidFill>
                   <a:srgbClr val="000000"/>
@@ -2135,6 +2137,7 @@
           <a:lstStyle xmlns:a="http://schemas.openxmlformats.org/drawingml/2006/main"/>
           <a:p xmlns:a="http://schemas.openxmlformats.org/drawingml/2006/main">
             <a:pPr algn="l">
+              <a:buNone/>
               <a:defRPr sz="1875" b="0">
                 <a:solidFill>
                   <a:srgbClr val="515664"/>
@@ -2193,6 +2196,7 @@
           <a:lstStyle xmlns:a="http://schemas.openxmlformats.org/drawingml/2006/main"/>
           <a:p xmlns:a="http://schemas.openxmlformats.org/drawingml/2006/main">
             <a:pPr algn="l">
+              <a:buNone/>
               <a:defRPr sz="1350" b="1">
                 <a:solidFill>
                   <a:srgbClr val="7A808F"/>
@@ -2218,14 +2222,14 @@
       </p:sp>
       <p:pic>
         <p:nvPicPr>
-          <p:cNvPr id="13" name=""/>
+          <p:cNvPr id="15" name=""/>
           <p:cNvPicPr>
             <a:picLocks xmlns:a="http://schemas.openxmlformats.org/drawingml/2006/main" noChangeAspect="1"/>
           </p:cNvPicPr>
           <p:nvPr/>
         </p:nvPicPr>
         <p:blipFill>
-          <a:blip xmlns:r="http://schemas.openxmlformats.org/officeDocument/2006/relationships" xmlns:a="http://schemas.openxmlformats.org/drawingml/2006/main" r:embed="R01638cee6d6742ac"/>
+          <a:blip xmlns:r="http://schemas.openxmlformats.org/officeDocument/2006/relationships" xmlns:a="http://schemas.openxmlformats.org/drawingml/2006/main" r:embed="Rf314b84f9b8349e5"/>
           <a:stretch xmlns:a="http://schemas.openxmlformats.org/drawingml/2006/main"/>
         </p:blipFill>
         <p:spPr>
@@ -2273,6 +2277,7 @@
           <a:lstStyle xmlns:a="http://schemas.openxmlformats.org/drawingml/2006/main"/>
           <a:p xmlns:a="http://schemas.openxmlformats.org/drawingml/2006/main">
             <a:pPr algn="ctr">
+              <a:buNone/>
               <a:defRPr sz="1125" b="1">
                 <a:solidFill>
                   <a:srgbClr val="5B2BFF"/>
@@ -2360,6 +2365,7 @@
           <a:lstStyle xmlns:a="http://schemas.openxmlformats.org/drawingml/2006/main"/>
           <a:p xmlns:a="http://schemas.openxmlformats.org/drawingml/2006/main">
             <a:pPr algn="l">
+              <a:buNone/>
               <a:defRPr sz="3000" b="1">
                 <a:solidFill>
                   <a:srgbClr val="000000"/>
@@ -2418,6 +2424,7 @@
           <a:lstStyle xmlns:a="http://schemas.openxmlformats.org/drawingml/2006/main"/>
           <a:p xmlns:a="http://schemas.openxmlformats.org/drawingml/2006/main">
             <a:pPr algn="r">
+              <a:buNone/>
               <a:defRPr sz="975" b="0">
                 <a:solidFill>
                   <a:srgbClr val="7A808F"/>
@@ -2476,6 +2483,7 @@
           <a:lstStyle xmlns:a="http://schemas.openxmlformats.org/drawingml/2006/main"/>
           <a:p xmlns:a="http://schemas.openxmlformats.org/drawingml/2006/main">
             <a:pPr algn="l">
+              <a:buNone/>
               <a:defRPr sz="975" b="0">
                 <a:solidFill>
                   <a:srgbClr val="7A808F"/>
@@ -2501,7 +2509,7 @@
       </p:sp>
       <p:cxnSp>
         <p:nvCxnSpPr>
-          <p:cNvPr id="39" name=""/>
+          <p:cNvPr id="103" name=""/>
           <p:cNvCxnSpPr/>
           <p:nvPr/>
         </p:nvCxnSpPr>
@@ -2556,6 +2564,7 @@
           <a:lstStyle xmlns:a="http://schemas.openxmlformats.org/drawingml/2006/main"/>
           <a:p xmlns:a="http://schemas.openxmlformats.org/drawingml/2006/main">
             <a:pPr algn="l">
+              <a:buNone/>
               <a:defRPr sz="1050" b="1">
                 <a:solidFill>
                   <a:srgbClr val="3D8DFF"/>
@@ -2614,6 +2623,7 @@
           <a:lstStyle xmlns:a="http://schemas.openxmlformats.org/drawingml/2006/main"/>
           <a:p xmlns:a="http://schemas.openxmlformats.org/drawingml/2006/main">
             <a:pPr algn="l">
+              <a:buNone/>
               <a:defRPr sz="1650" b="1">
                 <a:solidFill>
                   <a:srgbClr val="0E1230"/>
@@ -2672,6 +2682,7 @@
           <a:lstStyle xmlns:a="http://schemas.openxmlformats.org/drawingml/2006/main"/>
           <a:p xmlns:a="http://schemas.openxmlformats.org/drawingml/2006/main">
             <a:pPr algn="l">
+              <a:buNone/>
               <a:defRPr sz="1275" b="0">
                 <a:solidFill>
                   <a:srgbClr val="515664"/>
@@ -2697,7 +2708,7 @@
       </p:sp>
       <p:cxnSp>
         <p:nvCxnSpPr>
-          <p:cNvPr id="43" name=""/>
+          <p:cNvPr id="107" name=""/>
           <p:cNvCxnSpPr/>
           <p:nvPr/>
         </p:nvCxnSpPr>
@@ -2752,6 +2763,7 @@
           <a:lstStyle xmlns:a="http://schemas.openxmlformats.org/drawingml/2006/main"/>
           <a:p xmlns:a="http://schemas.openxmlformats.org/drawingml/2006/main">
             <a:pPr algn="l">
+              <a:buNone/>
               <a:defRPr sz="1050" b="1">
                 <a:solidFill>
                   <a:srgbClr val="3D8DFF"/>
@@ -2810,6 +2822,7 @@
           <a:lstStyle xmlns:a="http://schemas.openxmlformats.org/drawingml/2006/main"/>
           <a:p xmlns:a="http://schemas.openxmlformats.org/drawingml/2006/main">
             <a:pPr algn="l">
+              <a:buNone/>
               <a:defRPr sz="1650" b="1">
                 <a:solidFill>
                   <a:srgbClr val="0E1230"/>
@@ -2868,6 +2881,7 @@
           <a:lstStyle xmlns:a="http://schemas.openxmlformats.org/drawingml/2006/main"/>
           <a:p xmlns:a="http://schemas.openxmlformats.org/drawingml/2006/main">
             <a:pPr algn="l">
+              <a:buNone/>
               <a:defRPr sz="1275" b="0">
                 <a:solidFill>
                   <a:srgbClr val="515664"/>
@@ -2893,7 +2907,7 @@
       </p:sp>
       <p:cxnSp>
         <p:nvCxnSpPr>
-          <p:cNvPr id="47" name=""/>
+          <p:cNvPr id="111" name=""/>
           <p:cNvCxnSpPr/>
           <p:nvPr/>
         </p:nvCxnSpPr>
@@ -2948,6 +2962,7 @@
           <a:lstStyle xmlns:a="http://schemas.openxmlformats.org/drawingml/2006/main"/>
           <a:p xmlns:a="http://schemas.openxmlformats.org/drawingml/2006/main">
             <a:pPr algn="l">
+              <a:buNone/>
               <a:defRPr sz="1050" b="1">
                 <a:solidFill>
                   <a:srgbClr val="3D8DFF"/>
@@ -3006,6 +3021,7 @@
           <a:lstStyle xmlns:a="http://schemas.openxmlformats.org/drawingml/2006/main"/>
           <a:p xmlns:a="http://schemas.openxmlformats.org/drawingml/2006/main">
             <a:pPr algn="l">
+              <a:buNone/>
               <a:defRPr sz="1650" b="1">
                 <a:solidFill>
                   <a:srgbClr val="0E1230"/>
@@ -3064,6 +3080,7 @@
           <a:lstStyle xmlns:a="http://schemas.openxmlformats.org/drawingml/2006/main"/>
           <a:p xmlns:a="http://schemas.openxmlformats.org/drawingml/2006/main">
             <a:pPr algn="l">
+              <a:buNone/>
               <a:defRPr sz="1275" b="0">
                 <a:solidFill>
                   <a:srgbClr val="515664"/>
@@ -3089,7 +3106,7 @@
       </p:sp>
       <p:cxnSp>
         <p:nvCxnSpPr>
-          <p:cNvPr id="51" name=""/>
+          <p:cNvPr id="115" name=""/>
           <p:cNvCxnSpPr/>
           <p:nvPr/>
         </p:nvCxnSpPr>
@@ -3144,6 +3161,7 @@
           <a:lstStyle xmlns:a="http://schemas.openxmlformats.org/drawingml/2006/main"/>
           <a:p xmlns:a="http://schemas.openxmlformats.org/drawingml/2006/main">
             <a:pPr algn="l">
+              <a:buNone/>
               <a:defRPr sz="1050" b="1">
                 <a:solidFill>
                   <a:srgbClr val="3D8DFF"/>
@@ -3202,6 +3220,7 @@
           <a:lstStyle xmlns:a="http://schemas.openxmlformats.org/drawingml/2006/main"/>
           <a:p xmlns:a="http://schemas.openxmlformats.org/drawingml/2006/main">
             <a:pPr algn="l">
+              <a:buNone/>
               <a:defRPr sz="1650" b="1">
                 <a:solidFill>
                   <a:srgbClr val="0E1230"/>
@@ -3260,6 +3279,7 @@
           <a:lstStyle xmlns:a="http://schemas.openxmlformats.org/drawingml/2006/main"/>
           <a:p xmlns:a="http://schemas.openxmlformats.org/drawingml/2006/main">
             <a:pPr algn="l">
+              <a:buNone/>
               <a:defRPr sz="1275" b="0">
                 <a:solidFill>
                   <a:srgbClr val="515664"/>
@@ -3285,7 +3305,7 @@
       </p:sp>
       <p:cxnSp>
         <p:nvCxnSpPr>
-          <p:cNvPr id="55" name=""/>
+          <p:cNvPr id="119" name=""/>
           <p:cNvCxnSpPr/>
           <p:nvPr/>
         </p:nvCxnSpPr>
@@ -3340,6 +3360,7 @@
           <a:lstStyle xmlns:a="http://schemas.openxmlformats.org/drawingml/2006/main"/>
           <a:p xmlns:a="http://schemas.openxmlformats.org/drawingml/2006/main">
             <a:pPr algn="l">
+              <a:buNone/>
               <a:defRPr sz="1050" b="1">
                 <a:solidFill>
                   <a:srgbClr val="5B2BFF"/>
@@ -3398,6 +3419,7 @@
           <a:lstStyle xmlns:a="http://schemas.openxmlformats.org/drawingml/2006/main"/>
           <a:p xmlns:a="http://schemas.openxmlformats.org/drawingml/2006/main">
             <a:pPr algn="l">
+              <a:buNone/>
               <a:defRPr sz="1650" b="1">
                 <a:solidFill>
                   <a:srgbClr val="0E1230"/>
@@ -3456,6 +3478,7 @@
           <a:lstStyle xmlns:a="http://schemas.openxmlformats.org/drawingml/2006/main"/>
           <a:p xmlns:a="http://schemas.openxmlformats.org/drawingml/2006/main">
             <a:pPr algn="l">
+              <a:buNone/>
               <a:defRPr sz="1275" b="0">
                 <a:solidFill>
                   <a:srgbClr val="515664"/>
@@ -3481,7 +3504,7 @@
       </p:sp>
       <p:cxnSp>
         <p:nvCxnSpPr>
-          <p:cNvPr id="59" name=""/>
+          <p:cNvPr id="123" name=""/>
           <p:cNvCxnSpPr/>
           <p:nvPr/>
         </p:nvCxnSpPr>
@@ -3536,6 +3559,7 @@
           <a:lstStyle xmlns:a="http://schemas.openxmlformats.org/drawingml/2006/main"/>
           <a:p xmlns:a="http://schemas.openxmlformats.org/drawingml/2006/main">
             <a:pPr algn="l">
+              <a:buNone/>
               <a:defRPr sz="1050" b="1">
                 <a:solidFill>
                   <a:srgbClr val="515664"/>
@@ -3594,6 +3618,7 @@
           <a:lstStyle xmlns:a="http://schemas.openxmlformats.org/drawingml/2006/main"/>
           <a:p xmlns:a="http://schemas.openxmlformats.org/drawingml/2006/main">
             <a:pPr algn="l">
+              <a:buNone/>
               <a:defRPr sz="1650" b="1">
                 <a:solidFill>
                   <a:srgbClr val="0E1230"/>
@@ -3652,6 +3677,7 @@
           <a:lstStyle xmlns:a="http://schemas.openxmlformats.org/drawingml/2006/main"/>
           <a:p xmlns:a="http://schemas.openxmlformats.org/drawingml/2006/main">
             <a:pPr algn="l">
+              <a:buNone/>
               <a:defRPr sz="1275" b="0">
                 <a:solidFill>
                   <a:srgbClr val="515664"/>
@@ -3677,7 +3703,7 @@
       </p:sp>
       <p:cxnSp>
         <p:nvCxnSpPr>
-          <p:cNvPr id="63" name=""/>
+          <p:cNvPr id="127" name=""/>
           <p:cNvCxnSpPr/>
           <p:nvPr/>
         </p:nvCxnSpPr>
@@ -3732,6 +3758,7 @@
           <a:lstStyle xmlns:a="http://schemas.openxmlformats.org/drawingml/2006/main"/>
           <a:p xmlns:a="http://schemas.openxmlformats.org/drawingml/2006/main">
             <a:pPr algn="l">
+              <a:buNone/>
               <a:defRPr sz="1050" b="1">
                 <a:solidFill>
                   <a:srgbClr val="515664"/>
@@ -3790,6 +3817,7 @@
           <a:lstStyle xmlns:a="http://schemas.openxmlformats.org/drawingml/2006/main"/>
           <a:p xmlns:a="http://schemas.openxmlformats.org/drawingml/2006/main">
             <a:pPr algn="l">
+              <a:buNone/>
               <a:defRPr sz="1650" b="1">
                 <a:solidFill>
                   <a:srgbClr val="0E1230"/>
@@ -3848,6 +3876,7 @@
           <a:lstStyle xmlns:a="http://schemas.openxmlformats.org/drawingml/2006/main"/>
           <a:p xmlns:a="http://schemas.openxmlformats.org/drawingml/2006/main">
             <a:pPr algn="l">
+              <a:buNone/>
               <a:defRPr sz="1275" b="0">
                 <a:solidFill>
                   <a:srgbClr val="515664"/>
@@ -3873,7 +3902,7 @@
       </p:sp>
       <p:cxnSp>
         <p:nvCxnSpPr>
-          <p:cNvPr id="67" name=""/>
+          <p:cNvPr id="131" name=""/>
           <p:cNvCxnSpPr/>
           <p:nvPr/>
         </p:nvCxnSpPr>
@@ -3928,6 +3957,7 @@
           <a:lstStyle xmlns:a="http://schemas.openxmlformats.org/drawingml/2006/main"/>
           <a:p xmlns:a="http://schemas.openxmlformats.org/drawingml/2006/main">
             <a:pPr algn="l">
+              <a:buNone/>
               <a:defRPr sz="1050" b="1">
                 <a:solidFill>
                   <a:srgbClr val="515664"/>
@@ -3986,6 +4016,7 @@
           <a:lstStyle xmlns:a="http://schemas.openxmlformats.org/drawingml/2006/main"/>
           <a:p xmlns:a="http://schemas.openxmlformats.org/drawingml/2006/main">
             <a:pPr algn="l">
+              <a:buNone/>
               <a:defRPr sz="1650" b="1">
                 <a:solidFill>
                   <a:srgbClr val="0E1230"/>
@@ -4044,6 +4075,7 @@
           <a:lstStyle xmlns:a="http://schemas.openxmlformats.org/drawingml/2006/main"/>
           <a:p xmlns:a="http://schemas.openxmlformats.org/drawingml/2006/main">
             <a:pPr algn="l">
+              <a:buNone/>
               <a:defRPr sz="1275" b="0">
                 <a:solidFill>
                   <a:srgbClr val="515664"/>
@@ -4131,6 +4163,7 @@
           <a:lstStyle xmlns:a="http://schemas.openxmlformats.org/drawingml/2006/main"/>
           <a:p xmlns:a="http://schemas.openxmlformats.org/drawingml/2006/main">
             <a:pPr algn="l">
+              <a:buNone/>
               <a:defRPr sz="3000" b="1">
                 <a:solidFill>
                   <a:srgbClr val="000000"/>
@@ -4189,6 +4222,7 @@
           <a:lstStyle xmlns:a="http://schemas.openxmlformats.org/drawingml/2006/main"/>
           <a:p xmlns:a="http://schemas.openxmlformats.org/drawingml/2006/main">
             <a:pPr algn="r">
+              <a:buNone/>
               <a:defRPr sz="975" b="0">
                 <a:solidFill>
                   <a:srgbClr val="7A808F"/>
@@ -4247,6 +4281,7 @@
           <a:lstStyle xmlns:a="http://schemas.openxmlformats.org/drawingml/2006/main"/>
           <a:p xmlns:a="http://schemas.openxmlformats.org/drawingml/2006/main">
             <a:pPr algn="l">
+              <a:buNone/>
               <a:defRPr sz="975" b="0">
                 <a:solidFill>
                   <a:srgbClr val="7A808F"/>
@@ -4375,6 +4410,7 @@
           <a:lstStyle xmlns:a="http://schemas.openxmlformats.org/drawingml/2006/main"/>
           <a:p xmlns:a="http://schemas.openxmlformats.org/drawingml/2006/main">
             <a:pPr algn="l">
+              <a:buNone/>
               <a:defRPr sz="1275" b="1">
                 <a:solidFill>
                   <a:srgbClr val="3D8DFF"/>
@@ -4433,6 +4469,7 @@
           <a:lstStyle xmlns:a="http://schemas.openxmlformats.org/drawingml/2006/main"/>
           <a:p xmlns:a="http://schemas.openxmlformats.org/drawingml/2006/main">
             <a:pPr algn="l">
+              <a:buNone/>
               <a:defRPr sz="2175" b="1">
                 <a:solidFill>
                   <a:srgbClr val="0E1230"/>
@@ -4524,6 +4561,7 @@
           <a:lstStyle xmlns:a="http://schemas.openxmlformats.org/drawingml/2006/main"/>
           <a:p xmlns:a="http://schemas.openxmlformats.org/drawingml/2006/main">
             <a:pPr algn="l">
+              <a:buNone/>
               <a:defRPr sz="1425" b="0">
                 <a:solidFill>
                   <a:srgbClr val="0E1230"/>
@@ -4615,6 +4653,7 @@
           <a:lstStyle xmlns:a="http://schemas.openxmlformats.org/drawingml/2006/main"/>
           <a:p xmlns:a="http://schemas.openxmlformats.org/drawingml/2006/main">
             <a:pPr algn="l">
+              <a:buNone/>
               <a:defRPr sz="1425" b="0">
                 <a:solidFill>
                   <a:srgbClr val="0E1230"/>
@@ -4706,6 +4745,7 @@
           <a:lstStyle xmlns:a="http://schemas.openxmlformats.org/drawingml/2006/main"/>
           <a:p xmlns:a="http://schemas.openxmlformats.org/drawingml/2006/main">
             <a:pPr algn="l">
+              <a:buNone/>
               <a:defRPr sz="1425" b="0">
                 <a:solidFill>
                   <a:srgbClr val="0E1230"/>
@@ -4797,6 +4837,7 @@
           <a:lstStyle xmlns:a="http://schemas.openxmlformats.org/drawingml/2006/main"/>
           <a:p xmlns:a="http://schemas.openxmlformats.org/drawingml/2006/main">
             <a:pPr algn="l">
+              <a:buNone/>
               <a:defRPr sz="1425" b="0">
                 <a:solidFill>
                   <a:srgbClr val="0E1230"/>
@@ -4888,6 +4929,7 @@
           <a:lstStyle xmlns:a="http://schemas.openxmlformats.org/drawingml/2006/main"/>
           <a:p xmlns:a="http://schemas.openxmlformats.org/drawingml/2006/main">
             <a:pPr algn="l">
+              <a:buNone/>
               <a:defRPr sz="1425" b="0">
                 <a:solidFill>
                   <a:srgbClr val="0E1230"/>
@@ -4946,6 +4988,7 @@
           <a:lstStyle xmlns:a="http://schemas.openxmlformats.org/drawingml/2006/main"/>
           <a:p xmlns:a="http://schemas.openxmlformats.org/drawingml/2006/main">
             <a:pPr algn="l">
+              <a:buNone/>
               <a:defRPr sz="1275" b="1">
                 <a:solidFill>
                   <a:srgbClr val="FF3B8A"/>
@@ -5004,6 +5047,7 @@
           <a:lstStyle xmlns:a="http://schemas.openxmlformats.org/drawingml/2006/main"/>
           <a:p xmlns:a="http://schemas.openxmlformats.org/drawingml/2006/main">
             <a:pPr algn="l">
+              <a:buNone/>
               <a:defRPr sz="2175" b="1">
                 <a:solidFill>
                   <a:srgbClr val="0E1230"/>
@@ -5095,6 +5139,7 @@
           <a:lstStyle xmlns:a="http://schemas.openxmlformats.org/drawingml/2006/main"/>
           <a:p xmlns:a="http://schemas.openxmlformats.org/drawingml/2006/main">
             <a:pPr algn="l">
+              <a:buNone/>
               <a:defRPr sz="1425" b="0">
                 <a:solidFill>
                   <a:srgbClr val="0E1230"/>
@@ -5186,6 +5231,7 @@
           <a:lstStyle xmlns:a="http://schemas.openxmlformats.org/drawingml/2006/main"/>
           <a:p xmlns:a="http://schemas.openxmlformats.org/drawingml/2006/main">
             <a:pPr algn="l">
+              <a:buNone/>
               <a:defRPr sz="1425" b="0">
                 <a:solidFill>
                   <a:srgbClr val="0E1230"/>
@@ -5277,6 +5323,7 @@
           <a:lstStyle xmlns:a="http://schemas.openxmlformats.org/drawingml/2006/main"/>
           <a:p xmlns:a="http://schemas.openxmlformats.org/drawingml/2006/main">
             <a:pPr algn="l">
+              <a:buNone/>
               <a:defRPr sz="1425" b="0">
                 <a:solidFill>
                   <a:srgbClr val="0E1230"/>
@@ -5368,6 +5415,7 @@
           <a:lstStyle xmlns:a="http://schemas.openxmlformats.org/drawingml/2006/main"/>
           <a:p xmlns:a="http://schemas.openxmlformats.org/drawingml/2006/main">
             <a:pPr algn="l">
+              <a:buNone/>
               <a:defRPr sz="1425" b="0">
                 <a:solidFill>
                   <a:srgbClr val="0E1230"/>
@@ -5459,6 +5507,7 @@
           <a:lstStyle xmlns:a="http://schemas.openxmlformats.org/drawingml/2006/main"/>
           <a:p xmlns:a="http://schemas.openxmlformats.org/drawingml/2006/main">
             <a:pPr algn="l">
+              <a:buNone/>
               <a:defRPr sz="1425" b="0">
                 <a:solidFill>
                   <a:srgbClr val="0E1230"/>
@@ -5546,6 +5595,7 @@
           <a:lstStyle xmlns:a="http://schemas.openxmlformats.org/drawingml/2006/main"/>
           <a:p xmlns:a="http://schemas.openxmlformats.org/drawingml/2006/main">
             <a:pPr algn="l">
+              <a:buNone/>
               <a:defRPr sz="3000" b="1">
                 <a:solidFill>
                   <a:srgbClr val="000000"/>
@@ -5604,6 +5654,7 @@
           <a:lstStyle xmlns:a="http://schemas.openxmlformats.org/drawingml/2006/main"/>
           <a:p xmlns:a="http://schemas.openxmlformats.org/drawingml/2006/main">
             <a:pPr algn="r">
+              <a:buNone/>
               <a:defRPr sz="975" b="0">
                 <a:solidFill>
                   <a:srgbClr val="7A808F"/>
@@ -5662,6 +5713,7 @@
           <a:lstStyle xmlns:a="http://schemas.openxmlformats.org/drawingml/2006/main"/>
           <a:p xmlns:a="http://schemas.openxmlformats.org/drawingml/2006/main">
             <a:pPr algn="l">
+              <a:buNone/>
               <a:defRPr sz="975" b="0">
                 <a:solidFill>
                   <a:srgbClr val="7A808F"/>
@@ -5755,6 +5807,7 @@
           <a:lstStyle xmlns:a="http://schemas.openxmlformats.org/drawingml/2006/main"/>
           <a:p xmlns:a="http://schemas.openxmlformats.org/drawingml/2006/main">
             <a:pPr algn="l">
+              <a:buNone/>
               <a:defRPr sz="4800" b="1">
                 <a:solidFill>
                   <a:srgbClr val="0E1230"/>
@@ -5813,6 +5866,7 @@
           <a:lstStyle xmlns:a="http://schemas.openxmlformats.org/drawingml/2006/main"/>
           <a:p xmlns:a="http://schemas.openxmlformats.org/drawingml/2006/main">
             <a:pPr algn="l">
+              <a:buNone/>
               <a:defRPr sz="1800" b="1">
                 <a:solidFill>
                   <a:srgbClr val="0E1230"/>
@@ -5871,6 +5925,7 @@
           <a:lstStyle xmlns:a="http://schemas.openxmlformats.org/drawingml/2006/main"/>
           <a:p xmlns:a="http://schemas.openxmlformats.org/drawingml/2006/main">
             <a:pPr algn="l">
+              <a:buNone/>
               <a:defRPr sz="1350" b="0">
                 <a:solidFill>
                   <a:srgbClr val="515664"/>
@@ -5964,6 +6019,7 @@
           <a:lstStyle xmlns:a="http://schemas.openxmlformats.org/drawingml/2006/main"/>
           <a:p xmlns:a="http://schemas.openxmlformats.org/drawingml/2006/main">
             <a:pPr algn="l">
+              <a:buNone/>
               <a:defRPr sz="4800" b="1">
                 <a:solidFill>
                   <a:srgbClr val="3D8DFF"/>
@@ -6022,6 +6078,7 @@
           <a:lstStyle xmlns:a="http://schemas.openxmlformats.org/drawingml/2006/main"/>
           <a:p xmlns:a="http://schemas.openxmlformats.org/drawingml/2006/main">
             <a:pPr algn="l">
+              <a:buNone/>
               <a:defRPr sz="1800" b="1">
                 <a:solidFill>
                   <a:srgbClr val="0E1230"/>
@@ -6080,6 +6137,7 @@
           <a:lstStyle xmlns:a="http://schemas.openxmlformats.org/drawingml/2006/main"/>
           <a:p xmlns:a="http://schemas.openxmlformats.org/drawingml/2006/main">
             <a:pPr algn="l">
+              <a:buNone/>
               <a:defRPr sz="1350" b="0">
                 <a:solidFill>
                   <a:srgbClr val="515664"/>
@@ -6173,6 +6231,7 @@
           <a:lstStyle xmlns:a="http://schemas.openxmlformats.org/drawingml/2006/main"/>
           <a:p xmlns:a="http://schemas.openxmlformats.org/drawingml/2006/main">
             <a:pPr algn="l">
+              <a:buNone/>
               <a:defRPr sz="4800" b="1">
                 <a:solidFill>
                   <a:srgbClr val="0E1230"/>
@@ -6231,6 +6290,7 @@
           <a:lstStyle xmlns:a="http://schemas.openxmlformats.org/drawingml/2006/main"/>
           <a:p xmlns:a="http://schemas.openxmlformats.org/drawingml/2006/main">
             <a:pPr algn="l">
+              <a:buNone/>
               <a:defRPr sz="1800" b="1">
                 <a:solidFill>
                   <a:srgbClr val="0E1230"/>
@@ -6289,6 +6349,7 @@
           <a:lstStyle xmlns:a="http://schemas.openxmlformats.org/drawingml/2006/main"/>
           <a:p xmlns:a="http://schemas.openxmlformats.org/drawingml/2006/main">
             <a:pPr algn="l">
+              <a:buNone/>
               <a:defRPr sz="1350" b="0">
                 <a:solidFill>
                   <a:srgbClr val="515664"/>
@@ -6347,6 +6408,7 @@
           <a:lstStyle xmlns:a="http://schemas.openxmlformats.org/drawingml/2006/main"/>
           <a:p xmlns:a="http://schemas.openxmlformats.org/drawingml/2006/main">
             <a:pPr algn="l">
+              <a:buNone/>
               <a:defRPr sz="1500" b="1">
                 <a:solidFill>
                   <a:srgbClr val="0E1230"/>
@@ -6405,6 +6467,7 @@
           <a:lstStyle xmlns:a="http://schemas.openxmlformats.org/drawingml/2006/main"/>
           <a:p xmlns:a="http://schemas.openxmlformats.org/drawingml/2006/main">
             <a:pPr algn="ctr">
+              <a:buNone/>
               <a:defRPr sz="1500" b="0">
                 <a:solidFill>
                   <a:srgbClr val="515664"/>
@@ -6423,7 +6486,7 @@
                 <a:ea typeface="Helvetica Neue"/>
                 <a:cs typeface="Helvetica Neue"/>
               </a:rPr>
-              <a:t>fresh + retained restart  •  executor fencing/failover  •  state/effect proofs  •  JVM plugins  •  Linux ARM64 native composite startup</a:t>
+              <a:t>fresh + retained restart  •  governed profile activation  •  executor failover  •  state/effect proofs  •  JVM + Linux ARM64 native</a:t>
             </a:r>
           </a:p>
         </p:txBody>
@@ -6463,6 +6526,7 @@
           <a:lstStyle xmlns:a="http://schemas.openxmlformats.org/drawingml/2006/main"/>
           <a:p xmlns:a="http://schemas.openxmlformats.org/drawingml/2006/main">
             <a:pPr algn="ctr">
+              <a:buNone/>
               <a:defRPr sz="1275" b="1">
                 <a:solidFill>
                   <a:srgbClr val="2E9D68"/>
@@ -6481,7 +6545,7 @@
                 <a:ea typeface="Helvetica Neue"/>
                 <a:cs typeface="Helvetica Neue"/>
               </a:rPr>
-              <a:t>Independent final reviews: 0 unresolved Critical / High / Medium findings in ADR-013 scope</a:t>
+              <a:t>Independent final reviews: 0 unresolved Critical / High / Medium findings in ADR-013/015 scope</a:t>
             </a:r>
           </a:p>
         </p:txBody>
@@ -6550,6 +6614,7 @@
           <a:lstStyle xmlns:a="http://schemas.openxmlformats.org/drawingml/2006/main"/>
           <a:p xmlns:a="http://schemas.openxmlformats.org/drawingml/2006/main">
             <a:pPr algn="l">
+              <a:buNone/>
               <a:defRPr sz="1200" b="1">
                 <a:solidFill>
                   <a:srgbClr val="3D8DFF"/>
@@ -6608,6 +6673,7 @@
           <a:lstStyle xmlns:a="http://schemas.openxmlformats.org/drawingml/2006/main"/>
           <a:p xmlns:a="http://schemas.openxmlformats.org/drawingml/2006/main">
             <a:pPr algn="l">
+              <a:buNone/>
               <a:defRPr sz="4050" b="1">
                 <a:solidFill>
                   <a:srgbClr val="000000"/>
@@ -6633,7 +6699,7 @@
       </p:sp>
       <p:cxnSp>
         <p:nvCxnSpPr>
-          <p:cNvPr id="20" name=""/>
+          <p:cNvPr id="26" name=""/>
           <p:cNvCxnSpPr/>
           <p:nvPr/>
         </p:nvCxnSpPr>
@@ -6721,6 +6787,7 @@
           <a:lstStyle xmlns:a="http://schemas.openxmlformats.org/drawingml/2006/main"/>
           <a:p xmlns:a="http://schemas.openxmlformats.org/drawingml/2006/main">
             <a:pPr algn="l">
+              <a:buNone/>
               <a:defRPr sz="1275" b="1">
                 <a:solidFill>
                   <a:srgbClr val="3D8DFF"/>
@@ -6779,6 +6846,7 @@
           <a:lstStyle xmlns:a="http://schemas.openxmlformats.org/drawingml/2006/main"/>
           <a:p xmlns:a="http://schemas.openxmlformats.org/drawingml/2006/main">
             <a:pPr algn="l">
+              <a:buNone/>
               <a:defRPr sz="1500" b="1">
                 <a:solidFill>
                   <a:srgbClr val="0E1230"/>
@@ -6870,6 +6938,7 @@
           <a:lstStyle xmlns:a="http://schemas.openxmlformats.org/drawingml/2006/main"/>
           <a:p xmlns:a="http://schemas.openxmlformats.org/drawingml/2006/main">
             <a:pPr algn="l">
+              <a:buNone/>
               <a:defRPr sz="1275" b="1">
                 <a:solidFill>
                   <a:srgbClr val="3D8DFF"/>
@@ -6928,6 +6997,7 @@
           <a:lstStyle xmlns:a="http://schemas.openxmlformats.org/drawingml/2006/main"/>
           <a:p xmlns:a="http://schemas.openxmlformats.org/drawingml/2006/main">
             <a:pPr algn="l">
+              <a:buNone/>
               <a:defRPr sz="1500" b="1">
                 <a:solidFill>
                   <a:srgbClr val="0E1230"/>
@@ -7019,6 +7089,7 @@
           <a:lstStyle xmlns:a="http://schemas.openxmlformats.org/drawingml/2006/main"/>
           <a:p xmlns:a="http://schemas.openxmlformats.org/drawingml/2006/main">
             <a:pPr algn="l">
+              <a:buNone/>
               <a:defRPr sz="1275" b="1">
                 <a:solidFill>
                   <a:srgbClr val="3D8DFF"/>
@@ -7077,6 +7148,7 @@
           <a:lstStyle xmlns:a="http://schemas.openxmlformats.org/drawingml/2006/main"/>
           <a:p xmlns:a="http://schemas.openxmlformats.org/drawingml/2006/main">
             <a:pPr algn="l">
+              <a:buNone/>
               <a:defRPr sz="1500" b="1">
                 <a:solidFill>
                   <a:srgbClr val="0E1230"/>
@@ -7168,6 +7240,7 @@
           <a:lstStyle xmlns:a="http://schemas.openxmlformats.org/drawingml/2006/main"/>
           <a:p xmlns:a="http://schemas.openxmlformats.org/drawingml/2006/main">
             <a:pPr algn="l">
+              <a:buNone/>
               <a:defRPr sz="1275" b="1">
                 <a:solidFill>
                   <a:srgbClr val="3D8DFF"/>
@@ -7226,6 +7299,7 @@
           <a:lstStyle xmlns:a="http://schemas.openxmlformats.org/drawingml/2006/main"/>
           <a:p xmlns:a="http://schemas.openxmlformats.org/drawingml/2006/main">
             <a:pPr algn="l">
+              <a:buNone/>
               <a:defRPr sz="1500" b="1">
                 <a:solidFill>
                   <a:srgbClr val="0E1230"/>
@@ -7319,6 +7393,7 @@
           <a:lstStyle xmlns:a="http://schemas.openxmlformats.org/drawingml/2006/main"/>
           <a:p xmlns:a="http://schemas.openxmlformats.org/drawingml/2006/main">
             <a:pPr algn="ctr">
+              <a:buNone/>
               <a:defRPr sz="1725" b="1">
                 <a:solidFill>
                   <a:srgbClr val="FFFFFF"/>
@@ -7406,6 +7481,7 @@
           <a:lstStyle xmlns:a="http://schemas.openxmlformats.org/drawingml/2006/main"/>
           <a:p xmlns:a="http://schemas.openxmlformats.org/drawingml/2006/main">
             <a:pPr algn="l">
+              <a:buNone/>
               <a:defRPr sz="3000" b="1">
                 <a:solidFill>
                   <a:srgbClr val="000000"/>
@@ -7464,6 +7540,7 @@
           <a:lstStyle xmlns:a="http://schemas.openxmlformats.org/drawingml/2006/main"/>
           <a:p xmlns:a="http://schemas.openxmlformats.org/drawingml/2006/main">
             <a:pPr algn="r">
+              <a:buNone/>
               <a:defRPr sz="975" b="0">
                 <a:solidFill>
                   <a:srgbClr val="7A808F"/>
@@ -7522,6 +7599,7 @@
           <a:lstStyle xmlns:a="http://schemas.openxmlformats.org/drawingml/2006/main"/>
           <a:p xmlns:a="http://schemas.openxmlformats.org/drawingml/2006/main">
             <a:pPr algn="l">
+              <a:buNone/>
               <a:defRPr sz="975" b="0">
                 <a:solidFill>
                   <a:srgbClr val="7A808F"/>
@@ -7547,7 +7625,7 @@
       </p:sp>
       <p:cxnSp>
         <p:nvCxnSpPr>
-          <p:cNvPr id="28" name=""/>
+          <p:cNvPr id="40" name=""/>
           <p:cNvCxnSpPr/>
           <p:nvPr/>
         </p:nvCxnSpPr>
@@ -7569,7 +7647,7 @@
       </p:cxnSp>
       <p:cxnSp>
         <p:nvCxnSpPr>
-          <p:cNvPr id="29" name=""/>
+          <p:cNvPr id="41" name=""/>
           <p:cNvCxnSpPr/>
           <p:nvPr/>
         </p:nvCxnSpPr>
@@ -7591,7 +7669,7 @@
       </p:cxnSp>
       <p:cxnSp>
         <p:nvCxnSpPr>
-          <p:cNvPr id="30" name=""/>
+          <p:cNvPr id="42" name=""/>
           <p:cNvCxnSpPr/>
           <p:nvPr/>
         </p:nvCxnSpPr>
@@ -7681,6 +7759,7 @@
           <a:lstStyle xmlns:a="http://schemas.openxmlformats.org/drawingml/2006/main"/>
           <a:p xmlns:a="http://schemas.openxmlformats.org/drawingml/2006/main">
             <a:pPr algn="ctr">
+              <a:buNone/>
               <a:defRPr sz="1425" b="1">
                 <a:solidFill>
                   <a:srgbClr val="0E1230"/>
@@ -7774,6 +7853,7 @@
           <a:lstStyle xmlns:a="http://schemas.openxmlformats.org/drawingml/2006/main"/>
           <a:p xmlns:a="http://schemas.openxmlformats.org/drawingml/2006/main">
             <a:pPr algn="ctr">
+              <a:buNone/>
               <a:defRPr sz="1425" b="1">
                 <a:solidFill>
                   <a:srgbClr val="0E1230"/>
@@ -7867,6 +7947,7 @@
           <a:lstStyle xmlns:a="http://schemas.openxmlformats.org/drawingml/2006/main"/>
           <a:p xmlns:a="http://schemas.openxmlformats.org/drawingml/2006/main">
             <a:pPr algn="ctr">
+              <a:buNone/>
               <a:defRPr sz="1425" b="1">
                 <a:solidFill>
                   <a:srgbClr val="0E1230"/>
@@ -7960,6 +8041,7 @@
           <a:lstStyle xmlns:a="http://schemas.openxmlformats.org/drawingml/2006/main"/>
           <a:p xmlns:a="http://schemas.openxmlformats.org/drawingml/2006/main">
             <a:pPr algn="ctr">
+              <a:buNone/>
               <a:defRPr sz="1800" b="1">
                 <a:solidFill>
                   <a:srgbClr val="FFFFFF"/>
@@ -7983,6 +8065,7 @@
           </a:p>
           <a:p xmlns:a="http://schemas.openxmlformats.org/drawingml/2006/main">
             <a:pPr algn="ctr">
+              <a:buNone/>
               <a:defRPr sz="1800" b="1">
                 <a:solidFill>
                   <a:srgbClr val="FFFFFF"/>
@@ -8041,6 +8124,7 @@
           <a:lstStyle xmlns:a="http://schemas.openxmlformats.org/drawingml/2006/main"/>
           <a:p xmlns:a="http://schemas.openxmlformats.org/drawingml/2006/main">
             <a:pPr algn="ctr">
+              <a:buNone/>
               <a:defRPr sz="1350" b="1">
                 <a:solidFill>
                   <a:srgbClr val="FF3B8A"/>
@@ -8099,6 +8183,7 @@
           <a:lstStyle xmlns:a="http://schemas.openxmlformats.org/drawingml/2006/main"/>
           <a:p xmlns:a="http://schemas.openxmlformats.org/drawingml/2006/main">
             <a:pPr algn="l">
+              <a:buNone/>
               <a:defRPr sz="2025" b="1">
                 <a:solidFill>
                   <a:srgbClr val="0E1230"/>
@@ -8190,6 +8275,7 @@
           <a:lstStyle xmlns:a="http://schemas.openxmlformats.org/drawingml/2006/main"/>
           <a:p xmlns:a="http://schemas.openxmlformats.org/drawingml/2006/main">
             <a:pPr algn="l">
+              <a:buNone/>
               <a:defRPr sz="1575" b="0">
                 <a:solidFill>
                   <a:srgbClr val="0E1230"/>
@@ -8281,6 +8367,7 @@
           <a:lstStyle xmlns:a="http://schemas.openxmlformats.org/drawingml/2006/main"/>
           <a:p xmlns:a="http://schemas.openxmlformats.org/drawingml/2006/main">
             <a:pPr algn="l">
+              <a:buNone/>
               <a:defRPr sz="1575" b="0">
                 <a:solidFill>
                   <a:srgbClr val="0E1230"/>
@@ -8372,6 +8459,7 @@
           <a:lstStyle xmlns:a="http://schemas.openxmlformats.org/drawingml/2006/main"/>
           <a:p xmlns:a="http://schemas.openxmlformats.org/drawingml/2006/main">
             <a:pPr algn="l">
+              <a:buNone/>
               <a:defRPr sz="1575" b="0">
                 <a:solidFill>
                   <a:srgbClr val="0E1230"/>
@@ -8463,6 +8551,7 @@
           <a:lstStyle xmlns:a="http://schemas.openxmlformats.org/drawingml/2006/main"/>
           <a:p xmlns:a="http://schemas.openxmlformats.org/drawingml/2006/main">
             <a:pPr algn="l">
+              <a:buNone/>
               <a:defRPr sz="1575" b="0">
                 <a:solidFill>
                   <a:srgbClr val="0E1230"/>
@@ -8550,6 +8639,7 @@
           <a:lstStyle xmlns:a="http://schemas.openxmlformats.org/drawingml/2006/main"/>
           <a:p xmlns:a="http://schemas.openxmlformats.org/drawingml/2006/main">
             <a:pPr algn="l">
+              <a:buNone/>
               <a:defRPr sz="3000" b="1">
                 <a:solidFill>
                   <a:srgbClr val="000000"/>
@@ -8608,6 +8698,7 @@
           <a:lstStyle xmlns:a="http://schemas.openxmlformats.org/drawingml/2006/main"/>
           <a:p xmlns:a="http://schemas.openxmlformats.org/drawingml/2006/main">
             <a:pPr algn="r">
+              <a:buNone/>
               <a:defRPr sz="975" b="0">
                 <a:solidFill>
                   <a:srgbClr val="7A808F"/>
@@ -8666,6 +8757,7 @@
           <a:lstStyle xmlns:a="http://schemas.openxmlformats.org/drawingml/2006/main"/>
           <a:p xmlns:a="http://schemas.openxmlformats.org/drawingml/2006/main">
             <a:pPr algn="l">
+              <a:buNone/>
               <a:defRPr sz="975" b="0">
                 <a:solidFill>
                   <a:srgbClr val="7A808F"/>
@@ -8691,7 +8783,7 @@
       </p:sp>
       <p:cxnSp>
         <p:nvCxnSpPr>
-          <p:cNvPr id="31" name=""/>
+          <p:cNvPr id="49" name=""/>
           <p:cNvCxnSpPr/>
           <p:nvPr/>
         </p:nvCxnSpPr>
@@ -8713,7 +8805,7 @@
       </p:cxnSp>
       <p:cxnSp>
         <p:nvCxnSpPr>
-          <p:cNvPr id="32" name=""/>
+          <p:cNvPr id="50" name=""/>
           <p:cNvCxnSpPr/>
           <p:nvPr/>
         </p:nvCxnSpPr>
@@ -8735,7 +8827,7 @@
       </p:cxnSp>
       <p:cxnSp>
         <p:nvCxnSpPr>
-          <p:cNvPr id="33" name=""/>
+          <p:cNvPr id="51" name=""/>
           <p:cNvCxnSpPr/>
           <p:nvPr/>
         </p:nvCxnSpPr>
@@ -8757,7 +8849,7 @@
       </p:cxnSp>
       <p:cxnSp>
         <p:nvCxnSpPr>
-          <p:cNvPr id="34" name=""/>
+          <p:cNvPr id="52" name=""/>
           <p:cNvCxnSpPr/>
           <p:nvPr/>
         </p:nvCxnSpPr>
@@ -8779,7 +8871,7 @@
       </p:cxnSp>
       <p:cxnSp>
         <p:nvCxnSpPr>
-          <p:cNvPr id="35" name=""/>
+          <p:cNvPr id="53" name=""/>
           <p:cNvCxnSpPr/>
           <p:nvPr/>
         </p:nvCxnSpPr>
@@ -8801,7 +8893,7 @@
       </p:cxnSp>
       <p:cxnSp>
         <p:nvCxnSpPr>
-          <p:cNvPr id="36" name=""/>
+          <p:cNvPr id="54" name=""/>
           <p:cNvCxnSpPr/>
           <p:nvPr/>
         </p:nvCxnSpPr>
@@ -8891,6 +8983,7 @@
           <a:lstStyle xmlns:a="http://schemas.openxmlformats.org/drawingml/2006/main"/>
           <a:p xmlns:a="http://schemas.openxmlformats.org/drawingml/2006/main">
             <a:pPr algn="ctr">
+              <a:buNone/>
               <a:defRPr sz="1575" b="1">
                 <a:solidFill>
                   <a:srgbClr val="0E1230"/>
@@ -8919,6 +9012,7 @@
           </a:p>
           <a:p xmlns:a="http://schemas.openxmlformats.org/drawingml/2006/main">
             <a:pPr algn="ctr">
+              <a:buNone/>
               <a:defRPr sz="1575" b="1">
                 <a:solidFill>
                   <a:srgbClr val="0E1230"/>
@@ -8942,6 +9036,7 @@
           </a:p>
           <a:p xmlns:a="http://schemas.openxmlformats.org/drawingml/2006/main">
             <a:pPr algn="ctr">
+              <a:buNone/>
               <a:defRPr sz="1575" b="1">
                 <a:solidFill>
                   <a:srgbClr val="0E1230"/>
@@ -8965,6 +9060,7 @@
           </a:p>
           <a:p xmlns:a="http://schemas.openxmlformats.org/drawingml/2006/main">
             <a:pPr algn="ctr">
+              <a:buNone/>
               <a:defRPr sz="1575" b="1">
                 <a:solidFill>
                   <a:srgbClr val="0E1230"/>
@@ -9058,6 +9154,7 @@
           <a:lstStyle xmlns:a="http://schemas.openxmlformats.org/drawingml/2006/main"/>
           <a:p xmlns:a="http://schemas.openxmlformats.org/drawingml/2006/main">
             <a:pPr algn="ctr">
+              <a:buNone/>
               <a:defRPr sz="1950" b="1">
                 <a:solidFill>
                   <a:srgbClr val="3D8DFF"/>
@@ -9215,6 +9312,7 @@
           <a:lstStyle xmlns:a="http://schemas.openxmlformats.org/drawingml/2006/main"/>
           <a:p xmlns:a="http://schemas.openxmlformats.org/drawingml/2006/main">
             <a:pPr algn="ctr">
+              <a:buNone/>
               <a:defRPr sz="1350" b="1">
                 <a:solidFill>
                   <a:srgbClr val="0E1230"/>
@@ -9273,6 +9371,7 @@
           <a:lstStyle xmlns:a="http://schemas.openxmlformats.org/drawingml/2006/main"/>
           <a:p xmlns:a="http://schemas.openxmlformats.org/drawingml/2006/main">
             <a:pPr algn="ctr">
+              <a:buNone/>
               <a:defRPr sz="1350" b="1">
                 <a:solidFill>
                   <a:srgbClr val="0E1230"/>
@@ -9331,6 +9430,7 @@
           <a:lstStyle xmlns:a="http://schemas.openxmlformats.org/drawingml/2006/main"/>
           <a:p xmlns:a="http://schemas.openxmlformats.org/drawingml/2006/main">
             <a:pPr algn="ctr">
+              <a:buNone/>
               <a:defRPr sz="1350" b="1">
                 <a:solidFill>
                   <a:srgbClr val="0E1230"/>
@@ -9424,6 +9524,7 @@
           <a:lstStyle xmlns:a="http://schemas.openxmlformats.org/drawingml/2006/main"/>
           <a:p xmlns:a="http://schemas.openxmlformats.org/drawingml/2006/main">
             <a:pPr algn="ctr">
+              <a:buNone/>
               <a:defRPr sz="1650" b="1">
                 <a:solidFill>
                   <a:srgbClr val="FFFFFF"/>
@@ -9447,6 +9548,7 @@
           </a:p>
           <a:p xmlns:a="http://schemas.openxmlformats.org/drawingml/2006/main">
             <a:pPr algn="ctr">
+              <a:buNone/>
               <a:defRPr sz="1650" b="1">
                 <a:solidFill>
                   <a:srgbClr val="FFFFFF"/>
@@ -9540,6 +9642,7 @@
           <a:lstStyle xmlns:a="http://schemas.openxmlformats.org/drawingml/2006/main"/>
           <a:p xmlns:a="http://schemas.openxmlformats.org/drawingml/2006/main">
             <a:pPr algn="ctr">
+              <a:buNone/>
               <a:defRPr sz="1575" b="1">
                 <a:solidFill>
                   <a:srgbClr val="0E1230"/>
@@ -9568,6 +9671,7 @@
           </a:p>
           <a:p xmlns:a="http://schemas.openxmlformats.org/drawingml/2006/main">
             <a:pPr algn="ctr">
+              <a:buNone/>
               <a:defRPr sz="1575" b="1">
                 <a:solidFill>
                   <a:srgbClr val="0E1230"/>
@@ -9591,6 +9695,7 @@
           </a:p>
           <a:p xmlns:a="http://schemas.openxmlformats.org/drawingml/2006/main">
             <a:pPr algn="ctr">
+              <a:buNone/>
               <a:defRPr sz="1575" b="1">
                 <a:solidFill>
                   <a:srgbClr val="0E1230"/>
@@ -9614,6 +9719,7 @@
           </a:p>
           <a:p xmlns:a="http://schemas.openxmlformats.org/drawingml/2006/main">
             <a:pPr algn="ctr">
+              <a:buNone/>
               <a:defRPr sz="1575" b="1">
                 <a:solidFill>
                   <a:srgbClr val="0E1230"/>
@@ -9637,6 +9743,7 @@
           </a:p>
           <a:p xmlns:a="http://schemas.openxmlformats.org/drawingml/2006/main">
             <a:pPr algn="ctr">
+              <a:buNone/>
               <a:defRPr sz="1575" b="1">
                 <a:solidFill>
                   <a:srgbClr val="0E1230"/>
@@ -9730,6 +9837,7 @@
           <a:lstStyle xmlns:a="http://schemas.openxmlformats.org/drawingml/2006/main"/>
           <a:p xmlns:a="http://schemas.openxmlformats.org/drawingml/2006/main">
             <a:pPr algn="ctr">
+              <a:buNone/>
               <a:defRPr sz="1725" b="1">
                 <a:solidFill>
                   <a:srgbClr val="FFFFFF"/>
@@ -9788,6 +9896,7 @@
           <a:lstStyle xmlns:a="http://schemas.openxmlformats.org/drawingml/2006/main"/>
           <a:p xmlns:a="http://schemas.openxmlformats.org/drawingml/2006/main">
             <a:pPr algn="ctr">
+              <a:buNone/>
               <a:defRPr sz="1275" b="1">
                 <a:solidFill>
                   <a:srgbClr val="3D8DFF"/>
@@ -9846,6 +9955,7 @@
           <a:lstStyle xmlns:a="http://schemas.openxmlformats.org/drawingml/2006/main"/>
           <a:p xmlns:a="http://schemas.openxmlformats.org/drawingml/2006/main">
             <a:pPr algn="ctr">
+              <a:buNone/>
               <a:defRPr sz="1275" b="1">
                 <a:solidFill>
                   <a:srgbClr val="3D8DFF"/>
@@ -9933,6 +10043,7 @@
           <a:lstStyle xmlns:a="http://schemas.openxmlformats.org/drawingml/2006/main"/>
           <a:p xmlns:a="http://schemas.openxmlformats.org/drawingml/2006/main">
             <a:pPr algn="l">
+              <a:buNone/>
               <a:defRPr sz="3000" b="1">
                 <a:solidFill>
                   <a:srgbClr val="000000"/>
@@ -9991,6 +10102,7 @@
           <a:lstStyle xmlns:a="http://schemas.openxmlformats.org/drawingml/2006/main"/>
           <a:p xmlns:a="http://schemas.openxmlformats.org/drawingml/2006/main">
             <a:pPr algn="r">
+              <a:buNone/>
               <a:defRPr sz="975" b="0">
                 <a:solidFill>
                   <a:srgbClr val="7A808F"/>
@@ -10049,6 +10161,7 @@
           <a:lstStyle xmlns:a="http://schemas.openxmlformats.org/drawingml/2006/main"/>
           <a:p xmlns:a="http://schemas.openxmlformats.org/drawingml/2006/main">
             <a:pPr algn="l">
+              <a:buNone/>
               <a:defRPr sz="975" b="0">
                 <a:solidFill>
                   <a:srgbClr val="7A808F"/>
@@ -10262,6 +10375,7 @@
           <a:lstStyle xmlns:a="http://schemas.openxmlformats.org/drawingml/2006/main"/>
           <a:p xmlns:a="http://schemas.openxmlformats.org/drawingml/2006/main">
             <a:pPr algn="l">
+              <a:buNone/>
               <a:defRPr sz="2175" b="1">
                 <a:solidFill>
                   <a:srgbClr val="3D8DFF"/>
@@ -10287,7 +10401,7 @@
       </p:sp>
       <p:cxnSp>
         <p:nvCxnSpPr>
-          <p:cNvPr id="44" name=""/>
+          <p:cNvPr id="104" name=""/>
           <p:cNvCxnSpPr/>
           <p:nvPr/>
         </p:nvCxnSpPr>
@@ -10342,6 +10456,7 @@
           <a:lstStyle xmlns:a="http://schemas.openxmlformats.org/drawingml/2006/main"/>
           <a:p xmlns:a="http://schemas.openxmlformats.org/drawingml/2006/main">
             <a:pPr algn="l">
+              <a:buNone/>
               <a:defRPr sz="1875" b="1">
                 <a:solidFill>
                   <a:srgbClr val="0E1230"/>
@@ -10400,6 +10515,7 @@
           <a:lstStyle xmlns:a="http://schemas.openxmlformats.org/drawingml/2006/main"/>
           <a:p xmlns:a="http://schemas.openxmlformats.org/drawingml/2006/main">
             <a:pPr algn="l">
+              <a:buNone/>
               <a:defRPr sz="1425" b="0">
                 <a:solidFill>
                   <a:srgbClr val="515664"/>
@@ -10458,6 +10574,7 @@
           <a:lstStyle xmlns:a="http://schemas.openxmlformats.org/drawingml/2006/main"/>
           <a:p xmlns:a="http://schemas.openxmlformats.org/drawingml/2006/main">
             <a:pPr algn="l">
+              <a:buNone/>
               <a:defRPr sz="2175" b="1">
                 <a:solidFill>
                   <a:srgbClr val="3D8DFF"/>
@@ -10483,7 +10600,7 @@
       </p:sp>
       <p:cxnSp>
         <p:nvCxnSpPr>
-          <p:cNvPr id="48" name=""/>
+          <p:cNvPr id="108" name=""/>
           <p:cNvCxnSpPr/>
           <p:nvPr/>
         </p:nvCxnSpPr>
@@ -10538,6 +10655,7 @@
           <a:lstStyle xmlns:a="http://schemas.openxmlformats.org/drawingml/2006/main"/>
           <a:p xmlns:a="http://schemas.openxmlformats.org/drawingml/2006/main">
             <a:pPr algn="l">
+              <a:buNone/>
               <a:defRPr sz="1875" b="1">
                 <a:solidFill>
                   <a:srgbClr val="0E1230"/>
@@ -10596,6 +10714,7 @@
           <a:lstStyle xmlns:a="http://schemas.openxmlformats.org/drawingml/2006/main"/>
           <a:p xmlns:a="http://schemas.openxmlformats.org/drawingml/2006/main">
             <a:pPr algn="l">
+              <a:buNone/>
               <a:defRPr sz="1425" b="0">
                 <a:solidFill>
                   <a:srgbClr val="515664"/>
@@ -10654,6 +10773,7 @@
           <a:lstStyle xmlns:a="http://schemas.openxmlformats.org/drawingml/2006/main"/>
           <a:p xmlns:a="http://schemas.openxmlformats.org/drawingml/2006/main">
             <a:pPr algn="l">
+              <a:buNone/>
               <a:defRPr sz="2175" b="1">
                 <a:solidFill>
                   <a:srgbClr val="3D8DFF"/>
@@ -10679,7 +10799,7 @@
       </p:sp>
       <p:cxnSp>
         <p:nvCxnSpPr>
-          <p:cNvPr id="52" name=""/>
+          <p:cNvPr id="112" name=""/>
           <p:cNvCxnSpPr/>
           <p:nvPr/>
         </p:nvCxnSpPr>
@@ -10734,6 +10854,7 @@
           <a:lstStyle xmlns:a="http://schemas.openxmlformats.org/drawingml/2006/main"/>
           <a:p xmlns:a="http://schemas.openxmlformats.org/drawingml/2006/main">
             <a:pPr algn="l">
+              <a:buNone/>
               <a:defRPr sz="1875" b="1">
                 <a:solidFill>
                   <a:srgbClr val="0E1230"/>
@@ -10792,6 +10913,7 @@
           <a:lstStyle xmlns:a="http://schemas.openxmlformats.org/drawingml/2006/main"/>
           <a:p xmlns:a="http://schemas.openxmlformats.org/drawingml/2006/main">
             <a:pPr algn="l">
+              <a:buNone/>
               <a:defRPr sz="1425" b="0">
                 <a:solidFill>
                   <a:srgbClr val="515664"/>
@@ -10850,6 +10972,7 @@
           <a:lstStyle xmlns:a="http://schemas.openxmlformats.org/drawingml/2006/main"/>
           <a:p xmlns:a="http://schemas.openxmlformats.org/drawingml/2006/main">
             <a:pPr algn="l">
+              <a:buNone/>
               <a:defRPr sz="2175" b="1">
                 <a:solidFill>
                   <a:srgbClr val="3D8DFF"/>
@@ -10875,7 +10998,7 @@
       </p:sp>
       <p:cxnSp>
         <p:nvCxnSpPr>
-          <p:cNvPr id="56" name=""/>
+          <p:cNvPr id="116" name=""/>
           <p:cNvCxnSpPr/>
           <p:nvPr/>
         </p:nvCxnSpPr>
@@ -10930,6 +11053,7 @@
           <a:lstStyle xmlns:a="http://schemas.openxmlformats.org/drawingml/2006/main"/>
           <a:p xmlns:a="http://schemas.openxmlformats.org/drawingml/2006/main">
             <a:pPr algn="l">
+              <a:buNone/>
               <a:defRPr sz="1875" b="1">
                 <a:solidFill>
                   <a:srgbClr val="0E1230"/>
@@ -10988,6 +11112,7 @@
           <a:lstStyle xmlns:a="http://schemas.openxmlformats.org/drawingml/2006/main"/>
           <a:p xmlns:a="http://schemas.openxmlformats.org/drawingml/2006/main">
             <a:pPr algn="l">
+              <a:buNone/>
               <a:defRPr sz="1425" b="0">
                 <a:solidFill>
                   <a:srgbClr val="515664"/>
@@ -11046,6 +11171,7 @@
           <a:lstStyle xmlns:a="http://schemas.openxmlformats.org/drawingml/2006/main"/>
           <a:p xmlns:a="http://schemas.openxmlformats.org/drawingml/2006/main">
             <a:pPr algn="l">
+              <a:buNone/>
               <a:defRPr sz="2175" b="1">
                 <a:solidFill>
                   <a:srgbClr val="3D8DFF"/>
@@ -11071,7 +11197,7 @@
       </p:sp>
       <p:cxnSp>
         <p:nvCxnSpPr>
-          <p:cNvPr id="60" name=""/>
+          <p:cNvPr id="120" name=""/>
           <p:cNvCxnSpPr/>
           <p:nvPr/>
         </p:nvCxnSpPr>
@@ -11126,6 +11252,7 @@
           <a:lstStyle xmlns:a="http://schemas.openxmlformats.org/drawingml/2006/main"/>
           <a:p xmlns:a="http://schemas.openxmlformats.org/drawingml/2006/main">
             <a:pPr algn="l">
+              <a:buNone/>
               <a:defRPr sz="1875" b="1">
                 <a:solidFill>
                   <a:srgbClr val="0E1230"/>
@@ -11184,6 +11311,7 @@
           <a:lstStyle xmlns:a="http://schemas.openxmlformats.org/drawingml/2006/main"/>
           <a:p xmlns:a="http://schemas.openxmlformats.org/drawingml/2006/main">
             <a:pPr algn="l">
+              <a:buNone/>
               <a:defRPr sz="1425" b="0">
                 <a:solidFill>
                   <a:srgbClr val="515664"/>
@@ -11242,6 +11370,7 @@
           <a:lstStyle xmlns:a="http://schemas.openxmlformats.org/drawingml/2006/main"/>
           <a:p xmlns:a="http://schemas.openxmlformats.org/drawingml/2006/main">
             <a:pPr algn="l">
+              <a:buNone/>
               <a:defRPr sz="2175" b="1">
                 <a:solidFill>
                   <a:srgbClr val="3D8DFF"/>
@@ -11267,7 +11396,7 @@
       </p:sp>
       <p:cxnSp>
         <p:nvCxnSpPr>
-          <p:cNvPr id="64" name=""/>
+          <p:cNvPr id="124" name=""/>
           <p:cNvCxnSpPr/>
           <p:nvPr/>
         </p:nvCxnSpPr>
@@ -11322,6 +11451,7 @@
           <a:lstStyle xmlns:a="http://schemas.openxmlformats.org/drawingml/2006/main"/>
           <a:p xmlns:a="http://schemas.openxmlformats.org/drawingml/2006/main">
             <a:pPr algn="l">
+              <a:buNone/>
               <a:defRPr sz="1875" b="1">
                 <a:solidFill>
                   <a:srgbClr val="0E1230"/>
@@ -11380,6 +11510,7 @@
           <a:lstStyle xmlns:a="http://schemas.openxmlformats.org/drawingml/2006/main"/>
           <a:p xmlns:a="http://schemas.openxmlformats.org/drawingml/2006/main">
             <a:pPr algn="l">
+              <a:buNone/>
               <a:defRPr sz="1425" b="0">
                 <a:solidFill>
                   <a:srgbClr val="515664"/>
@@ -11473,6 +11604,7 @@
           <a:lstStyle xmlns:a="http://schemas.openxmlformats.org/drawingml/2006/main"/>
           <a:p xmlns:a="http://schemas.openxmlformats.org/drawingml/2006/main">
             <a:pPr algn="ctr">
+              <a:buNone/>
               <a:defRPr sz="1875" b="1">
                 <a:solidFill>
                   <a:srgbClr val="FFFFFF"/>
@@ -11560,6 +11692,7 @@
           <a:lstStyle xmlns:a="http://schemas.openxmlformats.org/drawingml/2006/main"/>
           <a:p xmlns:a="http://schemas.openxmlformats.org/drawingml/2006/main">
             <a:pPr algn="l">
+              <a:buNone/>
               <a:defRPr sz="3000" b="1">
                 <a:solidFill>
                   <a:srgbClr val="000000"/>
@@ -11618,6 +11751,7 @@
           <a:lstStyle xmlns:a="http://schemas.openxmlformats.org/drawingml/2006/main"/>
           <a:p xmlns:a="http://schemas.openxmlformats.org/drawingml/2006/main">
             <a:pPr algn="r">
+              <a:buNone/>
               <a:defRPr sz="975" b="0">
                 <a:solidFill>
                   <a:srgbClr val="7A808F"/>
@@ -11676,6 +11810,7 @@
           <a:lstStyle xmlns:a="http://schemas.openxmlformats.org/drawingml/2006/main"/>
           <a:p xmlns:a="http://schemas.openxmlformats.org/drawingml/2006/main">
             <a:pPr algn="l">
+              <a:buNone/>
               <a:defRPr sz="975" b="0">
                 <a:solidFill>
                   <a:srgbClr val="7A808F"/>
@@ -11804,6 +11939,7 @@
           <a:lstStyle xmlns:a="http://schemas.openxmlformats.org/drawingml/2006/main"/>
           <a:p xmlns:a="http://schemas.openxmlformats.org/drawingml/2006/main">
             <a:pPr algn="l">
+              <a:buNone/>
               <a:defRPr sz="1275" b="1">
                 <a:solidFill>
                   <a:srgbClr val="3D8DFF"/>
@@ -11862,6 +11998,7 @@
           <a:lstStyle xmlns:a="http://schemas.openxmlformats.org/drawingml/2006/main"/>
           <a:p xmlns:a="http://schemas.openxmlformats.org/drawingml/2006/main">
             <a:pPr algn="l">
+              <a:buNone/>
               <a:defRPr sz="2175" b="1">
                 <a:solidFill>
                   <a:srgbClr val="0E1230"/>
@@ -11953,6 +12090,7 @@
           <a:lstStyle xmlns:a="http://schemas.openxmlformats.org/drawingml/2006/main"/>
           <a:p xmlns:a="http://schemas.openxmlformats.org/drawingml/2006/main">
             <a:pPr algn="l">
+              <a:buNone/>
               <a:defRPr sz="1500" b="0">
                 <a:solidFill>
                   <a:srgbClr val="0E1230"/>
@@ -12044,6 +12182,7 @@
           <a:lstStyle xmlns:a="http://schemas.openxmlformats.org/drawingml/2006/main"/>
           <a:p xmlns:a="http://schemas.openxmlformats.org/drawingml/2006/main">
             <a:pPr algn="l">
+              <a:buNone/>
               <a:defRPr sz="1500" b="0">
                 <a:solidFill>
                   <a:srgbClr val="0E1230"/>
@@ -12135,6 +12274,7 @@
           <a:lstStyle xmlns:a="http://schemas.openxmlformats.org/drawingml/2006/main"/>
           <a:p xmlns:a="http://schemas.openxmlformats.org/drawingml/2006/main">
             <a:pPr algn="l">
+              <a:buNone/>
               <a:defRPr sz="1500" b="0">
                 <a:solidFill>
                   <a:srgbClr val="0E1230"/>
@@ -12226,6 +12366,7 @@
           <a:lstStyle xmlns:a="http://schemas.openxmlformats.org/drawingml/2006/main"/>
           <a:p xmlns:a="http://schemas.openxmlformats.org/drawingml/2006/main">
             <a:pPr algn="l">
+              <a:buNone/>
               <a:defRPr sz="1500" b="0">
                 <a:solidFill>
                   <a:srgbClr val="0E1230"/>
@@ -12284,6 +12425,7 @@
           <a:lstStyle xmlns:a="http://schemas.openxmlformats.org/drawingml/2006/main"/>
           <a:p xmlns:a="http://schemas.openxmlformats.org/drawingml/2006/main">
             <a:pPr algn="l">
+              <a:buNone/>
               <a:defRPr sz="1275" b="1">
                 <a:solidFill>
                   <a:srgbClr val="5B2BFF"/>
@@ -12342,6 +12484,7 @@
           <a:lstStyle xmlns:a="http://schemas.openxmlformats.org/drawingml/2006/main"/>
           <a:p xmlns:a="http://schemas.openxmlformats.org/drawingml/2006/main">
             <a:pPr algn="l">
+              <a:buNone/>
               <a:defRPr sz="2175" b="1">
                 <a:solidFill>
                   <a:srgbClr val="0E1230"/>
@@ -12433,6 +12576,7 @@
           <a:lstStyle xmlns:a="http://schemas.openxmlformats.org/drawingml/2006/main"/>
           <a:p xmlns:a="http://schemas.openxmlformats.org/drawingml/2006/main">
             <a:pPr algn="l">
+              <a:buNone/>
               <a:defRPr sz="1500" b="0">
                 <a:solidFill>
                   <a:srgbClr val="0E1230"/>
@@ -12524,6 +12668,7 @@
           <a:lstStyle xmlns:a="http://schemas.openxmlformats.org/drawingml/2006/main"/>
           <a:p xmlns:a="http://schemas.openxmlformats.org/drawingml/2006/main">
             <a:pPr algn="l">
+              <a:buNone/>
               <a:defRPr sz="1500" b="0">
                 <a:solidFill>
                   <a:srgbClr val="0E1230"/>
@@ -12615,6 +12760,7 @@
           <a:lstStyle xmlns:a="http://schemas.openxmlformats.org/drawingml/2006/main"/>
           <a:p xmlns:a="http://schemas.openxmlformats.org/drawingml/2006/main">
             <a:pPr algn="l">
+              <a:buNone/>
               <a:defRPr sz="1500" b="0">
                 <a:solidFill>
                   <a:srgbClr val="0E1230"/>
@@ -12706,6 +12852,7 @@
           <a:lstStyle xmlns:a="http://schemas.openxmlformats.org/drawingml/2006/main"/>
           <a:p xmlns:a="http://schemas.openxmlformats.org/drawingml/2006/main">
             <a:pPr algn="l">
+              <a:buNone/>
               <a:defRPr sz="1500" b="0">
                 <a:solidFill>
                   <a:srgbClr val="0E1230"/>
@@ -12795,6 +12942,7 @@
           <a:lstStyle xmlns:a="http://schemas.openxmlformats.org/drawingml/2006/main"/>
           <a:p xmlns:a="http://schemas.openxmlformats.org/drawingml/2006/main">
             <a:pPr algn="ctr">
+              <a:buNone/>
               <a:defRPr sz="1275" b="1">
                 <a:solidFill>
                   <a:srgbClr val="0E1230"/>
@@ -12818,6 +12966,7 @@
           </a:p>
           <a:p xmlns:a="http://schemas.openxmlformats.org/drawingml/2006/main">
             <a:pPr algn="ctr">
+              <a:buNone/>
               <a:defRPr sz="1275" b="1">
                 <a:solidFill>
                   <a:srgbClr val="0E1230"/>
@@ -12911,6 +13060,7 @@
           <a:lstStyle xmlns:a="http://schemas.openxmlformats.org/drawingml/2006/main"/>
           <a:p xmlns:a="http://schemas.openxmlformats.org/drawingml/2006/main">
             <a:pPr algn="ctr">
+              <a:buNone/>
               <a:defRPr sz="1500" b="1">
                 <a:solidFill>
                   <a:srgbClr val="0E1230"/>
@@ -12998,6 +13148,7 @@
           <a:lstStyle xmlns:a="http://schemas.openxmlformats.org/drawingml/2006/main"/>
           <a:p xmlns:a="http://schemas.openxmlformats.org/drawingml/2006/main">
             <a:pPr algn="l">
+              <a:buNone/>
               <a:defRPr sz="3000" b="1">
                 <a:solidFill>
                   <a:srgbClr val="000000"/>
@@ -13056,6 +13207,7 @@
           <a:lstStyle xmlns:a="http://schemas.openxmlformats.org/drawingml/2006/main"/>
           <a:p xmlns:a="http://schemas.openxmlformats.org/drawingml/2006/main">
             <a:pPr algn="r">
+              <a:buNone/>
               <a:defRPr sz="975" b="0">
                 <a:solidFill>
                   <a:srgbClr val="7A808F"/>
@@ -13114,6 +13266,7 @@
           <a:lstStyle xmlns:a="http://schemas.openxmlformats.org/drawingml/2006/main"/>
           <a:p xmlns:a="http://schemas.openxmlformats.org/drawingml/2006/main">
             <a:pPr algn="l">
+              <a:buNone/>
               <a:defRPr sz="975" b="0">
                 <a:solidFill>
                   <a:srgbClr val="7A808F"/>
@@ -13172,6 +13325,7 @@
           <a:lstStyle xmlns:a="http://schemas.openxmlformats.org/drawingml/2006/main"/>
           <a:p xmlns:a="http://schemas.openxmlformats.org/drawingml/2006/main">
             <a:pPr algn="l">
+              <a:buNone/>
               <a:defRPr sz="2250" b="1">
                 <a:solidFill>
                   <a:srgbClr val="3D8DFF"/>
@@ -13230,6 +13384,7 @@
           <a:lstStyle xmlns:a="http://schemas.openxmlformats.org/drawingml/2006/main"/>
           <a:p xmlns:a="http://schemas.openxmlformats.org/drawingml/2006/main">
             <a:pPr algn="l">
+              <a:buNone/>
               <a:defRPr sz="2025" b="1">
                 <a:solidFill>
                   <a:srgbClr val="0E1230"/>
@@ -13255,7 +13410,7 @@
       </p:sp>
       <p:cxnSp>
         <p:nvCxnSpPr>
-          <p:cNvPr id="24" name=""/>
+          <p:cNvPr id="52" name=""/>
           <p:cNvCxnSpPr/>
           <p:nvPr/>
         </p:nvCxnSpPr>
@@ -13310,6 +13465,7 @@
           <a:lstStyle xmlns:a="http://schemas.openxmlformats.org/drawingml/2006/main"/>
           <a:p xmlns:a="http://schemas.openxmlformats.org/drawingml/2006/main">
             <a:pPr algn="l">
+              <a:buNone/>
               <a:defRPr sz="1575" b="0">
                 <a:solidFill>
                   <a:srgbClr val="515664"/>
@@ -13333,6 +13489,7 @@
           </a:p>
           <a:p xmlns:a="http://schemas.openxmlformats.org/drawingml/2006/main">
             <a:pPr algn="l">
+              <a:buNone/>
               <a:defRPr sz="1575" b="0">
                 <a:solidFill>
                   <a:srgbClr val="515664"/>
@@ -13356,6 +13513,7 @@
           </a:p>
           <a:p xmlns:a="http://schemas.openxmlformats.org/drawingml/2006/main">
             <a:pPr algn="l">
+              <a:buNone/>
               <a:defRPr sz="1575" b="0">
                 <a:solidFill>
                   <a:srgbClr val="515664"/>
@@ -13379,6 +13537,7 @@
           </a:p>
           <a:p xmlns:a="http://schemas.openxmlformats.org/drawingml/2006/main">
             <a:pPr algn="l">
+              <a:buNone/>
               <a:defRPr sz="1575" b="0">
                 <a:solidFill>
                   <a:srgbClr val="515664"/>
@@ -13402,6 +13561,7 @@
           </a:p>
           <a:p xmlns:a="http://schemas.openxmlformats.org/drawingml/2006/main">
             <a:pPr algn="l">
+              <a:buNone/>
               <a:defRPr sz="1575" b="0">
                 <a:solidFill>
                   <a:srgbClr val="515664"/>
@@ -13425,6 +13585,7 @@
           </a:p>
           <a:p xmlns:a="http://schemas.openxmlformats.org/drawingml/2006/main">
             <a:pPr algn="l">
+              <a:buNone/>
               <a:defRPr sz="1575" b="0">
                 <a:solidFill>
                   <a:srgbClr val="515664"/>
@@ -13443,7 +13604,7 @@
                 <a:ea typeface="Helvetica Neue"/>
                 <a:cs typeface="Helvetica Neue"/>
               </a:rPr>
-              <a:t>composite / evidence-v1</a:t>
+              <a:t>composite / evidence-v1-gated</a:t>
             </a:r>
           </a:p>
         </p:txBody>
@@ -13483,6 +13644,7 @@
           <a:lstStyle xmlns:a="http://schemas.openxmlformats.org/drawingml/2006/main"/>
           <a:p xmlns:a="http://schemas.openxmlformats.org/drawingml/2006/main">
             <a:pPr algn="l">
+              <a:buNone/>
               <a:defRPr sz="2250" b="1">
                 <a:solidFill>
                   <a:srgbClr val="5B2BFF"/>
@@ -13541,6 +13703,7 @@
           <a:lstStyle xmlns:a="http://schemas.openxmlformats.org/drawingml/2006/main"/>
           <a:p xmlns:a="http://schemas.openxmlformats.org/drawingml/2006/main">
             <a:pPr algn="l">
+              <a:buNone/>
               <a:defRPr sz="2025" b="1">
                 <a:solidFill>
                   <a:srgbClr val="0E1230"/>
@@ -13566,7 +13729,7 @@
       </p:sp>
       <p:cxnSp>
         <p:nvCxnSpPr>
-          <p:cNvPr id="28" name=""/>
+          <p:cNvPr id="56" name=""/>
           <p:cNvCxnSpPr/>
           <p:nvPr/>
         </p:nvCxnSpPr>
@@ -13621,6 +13784,7 @@
           <a:lstStyle xmlns:a="http://schemas.openxmlformats.org/drawingml/2006/main"/>
           <a:p xmlns:a="http://schemas.openxmlformats.org/drawingml/2006/main">
             <a:pPr algn="l">
+              <a:buNone/>
               <a:defRPr sz="1575" b="0">
                 <a:solidFill>
                   <a:srgbClr val="515664"/>
@@ -13644,6 +13808,7 @@
           </a:p>
           <a:p xmlns:a="http://schemas.openxmlformats.org/drawingml/2006/main">
             <a:pPr algn="l">
+              <a:buNone/>
               <a:defRPr sz="1575" b="0">
                 <a:solidFill>
                   <a:srgbClr val="515664"/>
@@ -13667,6 +13832,7 @@
           </a:p>
           <a:p xmlns:a="http://schemas.openxmlformats.org/drawingml/2006/main">
             <a:pPr algn="l">
+              <a:buNone/>
               <a:defRPr sz="1575" b="0">
                 <a:solidFill>
                   <a:srgbClr val="515664"/>
@@ -13690,6 +13856,7 @@
           </a:p>
           <a:p xmlns:a="http://schemas.openxmlformats.org/drawingml/2006/main">
             <a:pPr algn="l">
+              <a:buNone/>
               <a:defRPr sz="1575" b="0">
                 <a:solidFill>
                   <a:srgbClr val="515664"/>
@@ -13713,6 +13880,7 @@
           </a:p>
           <a:p xmlns:a="http://schemas.openxmlformats.org/drawingml/2006/main">
             <a:pPr algn="l">
+              <a:buNone/>
               <a:defRPr sz="1575" b="0">
                 <a:solidFill>
                   <a:srgbClr val="515664"/>
@@ -13771,6 +13939,7 @@
           <a:lstStyle xmlns:a="http://schemas.openxmlformats.org/drawingml/2006/main"/>
           <a:p xmlns:a="http://schemas.openxmlformats.org/drawingml/2006/main">
             <a:pPr algn="l">
+              <a:buNone/>
               <a:defRPr sz="2250" b="1">
                 <a:solidFill>
                   <a:srgbClr val="0E1230"/>
@@ -13829,6 +13998,7 @@
           <a:lstStyle xmlns:a="http://schemas.openxmlformats.org/drawingml/2006/main"/>
           <a:p xmlns:a="http://schemas.openxmlformats.org/drawingml/2006/main">
             <a:pPr algn="l">
+              <a:buNone/>
               <a:defRPr sz="2025" b="1">
                 <a:solidFill>
                   <a:srgbClr val="0E1230"/>
@@ -13854,7 +14024,7 @@
       </p:sp>
       <p:cxnSp>
         <p:nvCxnSpPr>
-          <p:cNvPr id="32" name=""/>
+          <p:cNvPr id="60" name=""/>
           <p:cNvCxnSpPr/>
           <p:nvPr/>
         </p:nvCxnSpPr>
@@ -13909,6 +14079,7 @@
           <a:lstStyle xmlns:a="http://schemas.openxmlformats.org/drawingml/2006/main"/>
           <a:p xmlns:a="http://schemas.openxmlformats.org/drawingml/2006/main">
             <a:pPr algn="l">
+              <a:buNone/>
               <a:defRPr sz="1575" b="0">
                 <a:solidFill>
                   <a:srgbClr val="515664"/>
@@ -13932,6 +14103,7 @@
           </a:p>
           <a:p xmlns:a="http://schemas.openxmlformats.org/drawingml/2006/main">
             <a:pPr algn="l">
+              <a:buNone/>
               <a:defRPr sz="1575" b="0">
                 <a:solidFill>
                   <a:srgbClr val="515664"/>
@@ -13955,6 +14127,7 @@
           </a:p>
           <a:p xmlns:a="http://schemas.openxmlformats.org/drawingml/2006/main">
             <a:pPr algn="l">
+              <a:buNone/>
               <a:defRPr sz="1575" b="0">
                 <a:solidFill>
                   <a:srgbClr val="515664"/>
@@ -13978,6 +14151,7 @@
           </a:p>
           <a:p xmlns:a="http://schemas.openxmlformats.org/drawingml/2006/main">
             <a:pPr algn="l">
+              <a:buNone/>
               <a:defRPr sz="1575" b="0">
                 <a:solidFill>
                   <a:srgbClr val="515664"/>
@@ -14001,6 +14175,7 @@
           </a:p>
           <a:p xmlns:a="http://schemas.openxmlformats.org/drawingml/2006/main">
             <a:pPr algn="l">
+              <a:buNone/>
               <a:defRPr sz="1575" b="0">
                 <a:solidFill>
                   <a:srgbClr val="515664"/>
@@ -14059,6 +14234,7 @@
           <a:lstStyle xmlns:a="http://schemas.openxmlformats.org/drawingml/2006/main"/>
           <a:p xmlns:a="http://schemas.openxmlformats.org/drawingml/2006/main">
             <a:pPr algn="l">
+              <a:buNone/>
               <a:defRPr sz="1275" b="1">
                 <a:solidFill>
                   <a:srgbClr val="3D8DFF"/>
@@ -14117,6 +14293,7 @@
           <a:lstStyle xmlns:a="http://schemas.openxmlformats.org/drawingml/2006/main"/>
           <a:p xmlns:a="http://schemas.openxmlformats.org/drawingml/2006/main">
             <a:pPr algn="l">
+              <a:buNone/>
               <a:defRPr sz="1275" b="1">
                 <a:solidFill>
                   <a:srgbClr val="5B2BFF"/>
@@ -14175,6 +14352,7 @@
           <a:lstStyle xmlns:a="http://schemas.openxmlformats.org/drawingml/2006/main"/>
           <a:p xmlns:a="http://schemas.openxmlformats.org/drawingml/2006/main">
             <a:pPr algn="l">
+              <a:buNone/>
               <a:defRPr sz="1275" b="1">
                 <a:solidFill>
                   <a:srgbClr val="0E1230"/>
@@ -14262,6 +14440,7 @@
           <a:lstStyle xmlns:a="http://schemas.openxmlformats.org/drawingml/2006/main"/>
           <a:p xmlns:a="http://schemas.openxmlformats.org/drawingml/2006/main">
             <a:pPr algn="l">
+              <a:buNone/>
               <a:defRPr sz="3000" b="1">
                 <a:solidFill>
                   <a:srgbClr val="000000"/>
@@ -14320,6 +14499,7 @@
           <a:lstStyle xmlns:a="http://schemas.openxmlformats.org/drawingml/2006/main"/>
           <a:p xmlns:a="http://schemas.openxmlformats.org/drawingml/2006/main">
             <a:pPr algn="r">
+              <a:buNone/>
               <a:defRPr sz="975" b="0">
                 <a:solidFill>
                   <a:srgbClr val="7A808F"/>
@@ -14378,6 +14558,7 @@
           <a:lstStyle xmlns:a="http://schemas.openxmlformats.org/drawingml/2006/main"/>
           <a:p xmlns:a="http://schemas.openxmlformats.org/drawingml/2006/main">
             <a:pPr algn="l">
+              <a:buNone/>
               <a:defRPr sz="975" b="0">
                 <a:solidFill>
                   <a:srgbClr val="7A808F"/>
@@ -14471,6 +14652,7 @@
           <a:lstStyle xmlns:a="http://schemas.openxmlformats.org/drawingml/2006/main"/>
           <a:p xmlns:a="http://schemas.openxmlformats.org/drawingml/2006/main">
             <a:pPr algn="l">
+              <a:buNone/>
               <a:defRPr sz="1200" b="1">
                 <a:solidFill>
                   <a:srgbClr val="3D8DFF"/>
@@ -14529,6 +14711,7 @@
           <a:lstStyle xmlns:a="http://schemas.openxmlformats.org/drawingml/2006/main"/>
           <a:p xmlns:a="http://schemas.openxmlformats.org/drawingml/2006/main">
             <a:pPr algn="l">
+              <a:buNone/>
               <a:defRPr sz="1875" b="1">
                 <a:solidFill>
                   <a:srgbClr val="0E1230"/>
@@ -14622,6 +14805,7 @@
           <a:lstStyle xmlns:a="http://schemas.openxmlformats.org/drawingml/2006/main"/>
           <a:p xmlns:a="http://schemas.openxmlformats.org/drawingml/2006/main">
             <a:pPr algn="l">
+              <a:buNone/>
               <a:defRPr sz="1200" b="1">
                 <a:solidFill>
                   <a:srgbClr val="5B2BFF"/>
@@ -14680,6 +14864,7 @@
           <a:lstStyle xmlns:a="http://schemas.openxmlformats.org/drawingml/2006/main"/>
           <a:p xmlns:a="http://schemas.openxmlformats.org/drawingml/2006/main">
             <a:pPr algn="l">
+              <a:buNone/>
               <a:defRPr sz="1875" b="1">
                 <a:solidFill>
                   <a:srgbClr val="0E1230"/>
@@ -14773,6 +14958,7 @@
           <a:lstStyle xmlns:a="http://schemas.openxmlformats.org/drawingml/2006/main"/>
           <a:p xmlns:a="http://schemas.openxmlformats.org/drawingml/2006/main">
             <a:pPr algn="l">
+              <a:buNone/>
               <a:defRPr sz="1200" b="1">
                 <a:solidFill>
                   <a:srgbClr val="6DCBF4"/>
@@ -14831,6 +15017,7 @@
           <a:lstStyle xmlns:a="http://schemas.openxmlformats.org/drawingml/2006/main"/>
           <a:p xmlns:a="http://schemas.openxmlformats.org/drawingml/2006/main">
             <a:pPr algn="ctr">
+              <a:buNone/>
               <a:defRPr sz="1875" b="1">
                 <a:solidFill>
                   <a:srgbClr val="FFFFFF"/>
@@ -14889,6 +15076,7 @@
           <a:lstStyle xmlns:a="http://schemas.openxmlformats.org/drawingml/2006/main"/>
           <a:p xmlns:a="http://schemas.openxmlformats.org/drawingml/2006/main">
             <a:pPr algn="ctr">
+              <a:buNone/>
               <a:defRPr sz="1350" b="1">
                 <a:solidFill>
                   <a:srgbClr val="515664"/>
@@ -14976,6 +15164,7 @@
           <a:lstStyle xmlns:a="http://schemas.openxmlformats.org/drawingml/2006/main"/>
           <a:p xmlns:a="http://schemas.openxmlformats.org/drawingml/2006/main">
             <a:pPr algn="l">
+              <a:buNone/>
               <a:defRPr sz="3000" b="1">
                 <a:solidFill>
                   <a:srgbClr val="000000"/>
@@ -15034,6 +15223,7 @@
           <a:lstStyle xmlns:a="http://schemas.openxmlformats.org/drawingml/2006/main"/>
           <a:p xmlns:a="http://schemas.openxmlformats.org/drawingml/2006/main">
             <a:pPr algn="r">
+              <a:buNone/>
               <a:defRPr sz="975" b="0">
                 <a:solidFill>
                   <a:srgbClr val="7A808F"/>
@@ -15092,6 +15282,7 @@
           <a:lstStyle xmlns:a="http://schemas.openxmlformats.org/drawingml/2006/main"/>
           <a:p xmlns:a="http://schemas.openxmlformats.org/drawingml/2006/main">
             <a:pPr algn="l">
+              <a:buNone/>
               <a:defRPr sz="975" b="0">
                 <a:solidFill>
                   <a:srgbClr val="7A808F"/>
@@ -15117,7 +15308,7 @@
       </p:sp>
       <p:cxnSp>
         <p:nvCxnSpPr>
-          <p:cNvPr id="38" name=""/>
+          <p:cNvPr id="70" name=""/>
           <p:cNvCxnSpPr/>
           <p:nvPr/>
         </p:nvCxnSpPr>
@@ -15139,7 +15330,7 @@
       </p:cxnSp>
       <p:cxnSp>
         <p:nvCxnSpPr>
-          <p:cNvPr id="39" name=""/>
+          <p:cNvPr id="71" name=""/>
           <p:cNvCxnSpPr/>
           <p:nvPr/>
         </p:nvCxnSpPr>
@@ -15161,7 +15352,7 @@
       </p:cxnSp>
       <p:cxnSp>
         <p:nvCxnSpPr>
-          <p:cNvPr id="40" name=""/>
+          <p:cNvPr id="72" name=""/>
           <p:cNvCxnSpPr/>
           <p:nvPr/>
         </p:nvCxnSpPr>
@@ -15183,7 +15374,7 @@
       </p:cxnSp>
       <p:cxnSp>
         <p:nvCxnSpPr>
-          <p:cNvPr id="41" name=""/>
+          <p:cNvPr id="73" name=""/>
           <p:cNvCxnSpPr/>
           <p:nvPr/>
         </p:nvCxnSpPr>
@@ -15205,7 +15396,7 @@
       </p:cxnSp>
       <p:cxnSp>
         <p:nvCxnSpPr>
-          <p:cNvPr id="42" name=""/>
+          <p:cNvPr id="74" name=""/>
           <p:cNvCxnSpPr/>
           <p:nvPr/>
         </p:nvCxnSpPr>
@@ -15227,7 +15418,7 @@
       </p:cxnSp>
       <p:cxnSp>
         <p:nvCxnSpPr>
-          <p:cNvPr id="43" name=""/>
+          <p:cNvPr id="75" name=""/>
           <p:cNvCxnSpPr/>
           <p:nvPr/>
         </p:nvCxnSpPr>
@@ -15249,7 +15440,7 @@
       </p:cxnSp>
       <p:cxnSp>
         <p:nvCxnSpPr>
-          <p:cNvPr id="44" name=""/>
+          <p:cNvPr id="76" name=""/>
           <p:cNvCxnSpPr/>
           <p:nvPr/>
         </p:nvCxnSpPr>
@@ -15271,7 +15462,7 @@
       </p:cxnSp>
       <p:cxnSp>
         <p:nvCxnSpPr>
-          <p:cNvPr id="45" name=""/>
+          <p:cNvPr id="77" name=""/>
           <p:cNvCxnSpPr/>
           <p:nvPr/>
         </p:nvCxnSpPr>
@@ -15293,7 +15484,7 @@
       </p:cxnSp>
       <p:cxnSp>
         <p:nvCxnSpPr>
-          <p:cNvPr id="46" name=""/>
+          <p:cNvPr id="78" name=""/>
           <p:cNvCxnSpPr/>
           <p:nvPr/>
         </p:nvCxnSpPr>
@@ -15315,7 +15506,7 @@
       </p:cxnSp>
       <p:cxnSp>
         <p:nvCxnSpPr>
-          <p:cNvPr id="47" name=""/>
+          <p:cNvPr id="79" name=""/>
           <p:cNvCxnSpPr/>
           <p:nvPr/>
         </p:nvCxnSpPr>
@@ -15337,7 +15528,7 @@
       </p:cxnSp>
       <p:cxnSp>
         <p:nvCxnSpPr>
-          <p:cNvPr id="48" name=""/>
+          <p:cNvPr id="80" name=""/>
           <p:cNvCxnSpPr/>
           <p:nvPr/>
         </p:nvCxnSpPr>
@@ -15359,7 +15550,7 @@
       </p:cxnSp>
       <p:cxnSp>
         <p:nvCxnSpPr>
-          <p:cNvPr id="49" name=""/>
+          <p:cNvPr id="81" name=""/>
           <p:cNvCxnSpPr/>
           <p:nvPr/>
         </p:nvCxnSpPr>
@@ -15381,7 +15572,7 @@
       </p:cxnSp>
       <p:cxnSp>
         <p:nvCxnSpPr>
-          <p:cNvPr id="50" name=""/>
+          <p:cNvPr id="82" name=""/>
           <p:cNvCxnSpPr/>
           <p:nvPr/>
         </p:nvCxnSpPr>
@@ -15466,11 +15657,12 @@
         </p:spPr>
         <p:txBody>
           <a:bodyPr xmlns:a="http://schemas.openxmlformats.org/drawingml/2006/main" lIns="0" tIns="0" rIns="0" bIns="0" anchor="ctr">
-            <a:normAutofit fontScale="88802"/>
+            <a:normAutofit fontScale="99643"/>
           </a:bodyPr>
           <a:lstStyle xmlns:a="http://schemas.openxmlformats.org/drawingml/2006/main"/>
           <a:p xmlns:a="http://schemas.openxmlformats.org/drawingml/2006/main">
             <a:pPr algn="ctr">
+              <a:buNone/>
               <a:defRPr sz="1650" b="1">
                 <a:solidFill>
                   <a:srgbClr val="FFFFFF"/>
@@ -15489,11 +15681,12 @@
                 <a:ea typeface="Helvetica Neue"/>
                 <a:cs typeface="Helvetica Neue"/>
               </a:rPr>
-              <a:t>Canonical profile</a:t>
+              <a:t>Governed profile epoch</a:t>
             </a:r>
           </a:p>
           <a:p xmlns:a="http://schemas.openxmlformats.org/drawingml/2006/main">
             <a:pPr algn="ctr">
+              <a:buNone/>
               <a:defRPr sz="1650" b="1">
                 <a:solidFill>
                   <a:srgbClr val="FFFFFF"/>
@@ -15512,7 +15705,18 @@
                 <a:ea typeface="Helvetica Neue"/>
                 <a:cs typeface="Helvetica Neue"/>
               </a:rPr>
-              <a:t>fixed order • routes • versions • quotas • activations</a:t>
+              <a:t>order</a:t>
+            </a:r>
+            <a:r>
+              <a:rPr sz="1650" b="1">
+                <a:solidFill>
+                  <a:srgbClr val="FFFFFF"/>
+                </a:solidFill>
+                <a:latin typeface="Helvetica Neue"/>
+                <a:ea typeface="Helvetica Neue"/>
+                <a:cs typeface="Helvetica Neue"/>
+              </a:rPr>
+              <a:t> • routes • versions • quotas • activations</a:t>
             </a:r>
           </a:p>
         </p:txBody>
@@ -15587,6 +15791,7 @@
           <a:lstStyle xmlns:a="http://schemas.openxmlformats.org/drawingml/2006/main"/>
           <a:p xmlns:a="http://schemas.openxmlformats.org/drawingml/2006/main">
             <a:pPr algn="ctr">
+              <a:buNone/>
               <a:defRPr sz="1650" b="1">
                 <a:solidFill>
                   <a:srgbClr val="0E1230"/>
@@ -15645,6 +15850,7 @@
           <a:lstStyle xmlns:a="http://schemas.openxmlformats.org/drawingml/2006/main"/>
           <a:p xmlns:a="http://schemas.openxmlformats.org/drawingml/2006/main">
             <a:pPr algn="ctr">
+              <a:buNone/>
               <a:defRPr sz="1200" b="0">
                 <a:solidFill>
                   <a:srgbClr val="515664"/>
@@ -15738,6 +15944,7 @@
           <a:lstStyle xmlns:a="http://schemas.openxmlformats.org/drawingml/2006/main"/>
           <a:p xmlns:a="http://schemas.openxmlformats.org/drawingml/2006/main">
             <a:pPr algn="ctr">
+              <a:buNone/>
               <a:defRPr sz="1650" b="1">
                 <a:solidFill>
                   <a:srgbClr val="0E1230"/>
@@ -15796,6 +16003,7 @@
           <a:lstStyle xmlns:a="http://schemas.openxmlformats.org/drawingml/2006/main"/>
           <a:p xmlns:a="http://schemas.openxmlformats.org/drawingml/2006/main">
             <a:pPr algn="ctr">
+              <a:buNone/>
               <a:defRPr sz="1200" b="0">
                 <a:solidFill>
                   <a:srgbClr val="515664"/>
@@ -15889,6 +16097,7 @@
           <a:lstStyle xmlns:a="http://schemas.openxmlformats.org/drawingml/2006/main"/>
           <a:p xmlns:a="http://schemas.openxmlformats.org/drawingml/2006/main">
             <a:pPr algn="ctr">
+              <a:buNone/>
               <a:defRPr sz="1650" b="1">
                 <a:solidFill>
                   <a:srgbClr val="0E1230"/>
@@ -15947,6 +16156,7 @@
           <a:lstStyle xmlns:a="http://schemas.openxmlformats.org/drawingml/2006/main"/>
           <a:p xmlns:a="http://schemas.openxmlformats.org/drawingml/2006/main">
             <a:pPr algn="ctr">
+              <a:buNone/>
               <a:defRPr sz="1200" b="0">
                 <a:solidFill>
                   <a:srgbClr val="515664"/>
@@ -16040,6 +16250,7 @@
           <a:lstStyle xmlns:a="http://schemas.openxmlformats.org/drawingml/2006/main"/>
           <a:p xmlns:a="http://schemas.openxmlformats.org/drawingml/2006/main">
             <a:pPr algn="ctr">
+              <a:buNone/>
               <a:defRPr sz="1650" b="1">
                 <a:solidFill>
                   <a:srgbClr val="0E1230"/>
@@ -16098,6 +16309,7 @@
           <a:lstStyle xmlns:a="http://schemas.openxmlformats.org/drawingml/2006/main"/>
           <a:p xmlns:a="http://schemas.openxmlformats.org/drawingml/2006/main">
             <a:pPr algn="ctr">
+              <a:buNone/>
               <a:defRPr sz="1200" b="0">
                 <a:solidFill>
                   <a:srgbClr val="515664"/>
@@ -16191,6 +16403,7 @@
           <a:lstStyle xmlns:a="http://schemas.openxmlformats.org/drawingml/2006/main"/>
           <a:p xmlns:a="http://schemas.openxmlformats.org/drawingml/2006/main">
             <a:pPr algn="ctr">
+              <a:buNone/>
               <a:defRPr sz="1575" b="1">
                 <a:solidFill>
                   <a:srgbClr val="5B2BFF"/>
@@ -16284,6 +16497,7 @@
           <a:lstStyle xmlns:a="http://schemas.openxmlformats.org/drawingml/2006/main"/>
           <a:p xmlns:a="http://schemas.openxmlformats.org/drawingml/2006/main">
             <a:pPr algn="ctr">
+              <a:buNone/>
               <a:defRPr sz="1575" b="1">
                 <a:solidFill>
                   <a:srgbClr val="FFFFFF"/>
@@ -16371,6 +16585,7 @@
           <a:lstStyle xmlns:a="http://schemas.openxmlformats.org/drawingml/2006/main"/>
           <a:p xmlns:a="http://schemas.openxmlformats.org/drawingml/2006/main">
             <a:pPr algn="l">
+              <a:buNone/>
               <a:defRPr sz="3000" b="1">
                 <a:solidFill>
                   <a:srgbClr val="000000"/>
@@ -16429,6 +16644,7 @@
           <a:lstStyle xmlns:a="http://schemas.openxmlformats.org/drawingml/2006/main"/>
           <a:p xmlns:a="http://schemas.openxmlformats.org/drawingml/2006/main">
             <a:pPr algn="r">
+              <a:buNone/>
               <a:defRPr sz="975" b="0">
                 <a:solidFill>
                   <a:srgbClr val="7A808F"/>
@@ -16487,6 +16703,7 @@
           <a:lstStyle xmlns:a="http://schemas.openxmlformats.org/drawingml/2006/main"/>
           <a:p xmlns:a="http://schemas.openxmlformats.org/drawingml/2006/main">
             <a:pPr algn="l">
+              <a:buNone/>
               <a:defRPr sz="975" b="0">
                 <a:solidFill>
                   <a:srgbClr val="7A808F"/>
@@ -16512,7 +16729,7 @@
       </p:sp>
       <p:cxnSp>
         <p:nvCxnSpPr>
-          <p:cNvPr id="31" name=""/>
+          <p:cNvPr id="57" name=""/>
           <p:cNvCxnSpPr/>
           <p:nvPr/>
         </p:nvCxnSpPr>
@@ -16534,7 +16751,7 @@
       </p:cxnSp>
       <p:cxnSp>
         <p:nvCxnSpPr>
-          <p:cNvPr id="32" name=""/>
+          <p:cNvPr id="58" name=""/>
           <p:cNvCxnSpPr/>
           <p:nvPr/>
         </p:nvCxnSpPr>
@@ -16556,7 +16773,7 @@
       </p:cxnSp>
       <p:cxnSp>
         <p:nvCxnSpPr>
-          <p:cNvPr id="33" name=""/>
+          <p:cNvPr id="59" name=""/>
           <p:cNvCxnSpPr/>
           <p:nvPr/>
         </p:nvCxnSpPr>
@@ -16578,7 +16795,7 @@
       </p:cxnSp>
       <p:cxnSp>
         <p:nvCxnSpPr>
-          <p:cNvPr id="34" name=""/>
+          <p:cNvPr id="60" name=""/>
           <p:cNvCxnSpPr/>
           <p:nvPr/>
         </p:nvCxnSpPr>
@@ -16600,7 +16817,7 @@
       </p:cxnSp>
       <p:cxnSp>
         <p:nvCxnSpPr>
-          <p:cNvPr id="35" name=""/>
+          <p:cNvPr id="61" name=""/>
           <p:cNvCxnSpPr/>
           <p:nvPr/>
         </p:nvCxnSpPr>
@@ -16622,7 +16839,7 @@
       </p:cxnSp>
       <p:cxnSp>
         <p:nvCxnSpPr>
-          <p:cNvPr id="36" name=""/>
+          <p:cNvPr id="62" name=""/>
           <p:cNvCxnSpPr/>
           <p:nvPr/>
         </p:nvCxnSpPr>
@@ -16644,7 +16861,7 @@
       </p:cxnSp>
       <p:cxnSp>
         <p:nvCxnSpPr>
-          <p:cNvPr id="37" name=""/>
+          <p:cNvPr id="63" name=""/>
           <p:cNvCxnSpPr/>
           <p:nvPr/>
         </p:nvCxnSpPr>
@@ -16666,7 +16883,7 @@
       </p:cxnSp>
       <p:cxnSp>
         <p:nvCxnSpPr>
-          <p:cNvPr id="38" name=""/>
+          <p:cNvPr id="64" name=""/>
           <p:cNvCxnSpPr/>
           <p:nvPr/>
         </p:nvCxnSpPr>
@@ -16688,7 +16905,7 @@
       </p:cxnSp>
       <p:cxnSp>
         <p:nvCxnSpPr>
-          <p:cNvPr id="39" name=""/>
+          <p:cNvPr id="65" name=""/>
           <p:cNvCxnSpPr/>
           <p:nvPr/>
         </p:nvCxnSpPr>
@@ -16710,7 +16927,7 @@
       </p:cxnSp>
       <p:cxnSp>
         <p:nvCxnSpPr>
-          <p:cNvPr id="40" name=""/>
+          <p:cNvPr id="66" name=""/>
           <p:cNvCxnSpPr/>
           <p:nvPr/>
         </p:nvCxnSpPr>
@@ -16800,6 +17017,7 @@
           <a:lstStyle xmlns:a="http://schemas.openxmlformats.org/drawingml/2006/main"/>
           <a:p xmlns:a="http://schemas.openxmlformats.org/drawingml/2006/main">
             <a:pPr algn="ctr">
+              <a:buNone/>
               <a:defRPr sz="1650" b="1">
                 <a:solidFill>
                   <a:srgbClr val="0E1230"/>
@@ -16823,6 +17041,7 @@
           </a:p>
           <a:p xmlns:a="http://schemas.openxmlformats.org/drawingml/2006/main">
             <a:pPr algn="ctr">
+              <a:buNone/>
               <a:defRPr sz="1650" b="1">
                 <a:solidFill>
                   <a:srgbClr val="0E1230"/>
@@ -16916,6 +17135,7 @@
           <a:lstStyle xmlns:a="http://schemas.openxmlformats.org/drawingml/2006/main"/>
           <a:p xmlns:a="http://schemas.openxmlformats.org/drawingml/2006/main">
             <a:pPr algn="ctr">
+              <a:buNone/>
               <a:defRPr sz="1575" b="1">
                 <a:solidFill>
                   <a:srgbClr val="FFFFFF"/>
@@ -16939,6 +17159,7 @@
           </a:p>
           <a:p xmlns:a="http://schemas.openxmlformats.org/drawingml/2006/main">
             <a:pPr algn="ctr">
+              <a:buNone/>
               <a:defRPr sz="1575" b="1">
                 <a:solidFill>
                   <a:srgbClr val="FFFFFF"/>
@@ -17032,6 +17253,7 @@
           <a:lstStyle xmlns:a="http://schemas.openxmlformats.org/drawingml/2006/main"/>
           <a:p xmlns:a="http://schemas.openxmlformats.org/drawingml/2006/main">
             <a:pPr algn="ctr">
+              <a:buNone/>
               <a:defRPr sz="1500" b="1">
                 <a:solidFill>
                   <a:srgbClr val="0E1230"/>
@@ -17055,6 +17277,7 @@
           </a:p>
           <a:p xmlns:a="http://schemas.openxmlformats.org/drawingml/2006/main">
             <a:pPr algn="ctr">
+              <a:buNone/>
               <a:defRPr sz="1500" b="1">
                 <a:solidFill>
                   <a:srgbClr val="0E1230"/>
@@ -17148,6 +17371,7 @@
           <a:lstStyle xmlns:a="http://schemas.openxmlformats.org/drawingml/2006/main"/>
           <a:p xmlns:a="http://schemas.openxmlformats.org/drawingml/2006/main">
             <a:pPr algn="ctr">
+              <a:buNone/>
               <a:defRPr sz="1500" b="1">
                 <a:solidFill>
                   <a:srgbClr val="0E1230"/>
@@ -17171,6 +17395,7 @@
           </a:p>
           <a:p xmlns:a="http://schemas.openxmlformats.org/drawingml/2006/main">
             <a:pPr algn="ctr">
+              <a:buNone/>
               <a:defRPr sz="1500" b="1">
                 <a:solidFill>
                   <a:srgbClr val="0E1230"/>
@@ -17264,6 +17489,7 @@
           <a:lstStyle xmlns:a="http://schemas.openxmlformats.org/drawingml/2006/main"/>
           <a:p xmlns:a="http://schemas.openxmlformats.org/drawingml/2006/main">
             <a:pPr algn="ctr">
+              <a:buNone/>
               <a:defRPr sz="1575" b="1">
                 <a:solidFill>
                   <a:srgbClr val="5B2BFF"/>
@@ -17287,6 +17513,7 @@
           </a:p>
           <a:p xmlns:a="http://schemas.openxmlformats.org/drawingml/2006/main">
             <a:pPr algn="ctr">
+              <a:buNone/>
               <a:defRPr sz="1575" b="1">
                 <a:solidFill>
                   <a:srgbClr val="5B2BFF"/>
@@ -17380,6 +17607,7 @@
           <a:lstStyle xmlns:a="http://schemas.openxmlformats.org/drawingml/2006/main"/>
           <a:p xmlns:a="http://schemas.openxmlformats.org/drawingml/2006/main">
             <a:pPr algn="ctr">
+              <a:buNone/>
               <a:defRPr sz="1650" b="1">
                 <a:solidFill>
                   <a:srgbClr val="FFFFFF"/>
@@ -17403,6 +17631,7 @@
           </a:p>
           <a:p xmlns:a="http://schemas.openxmlformats.org/drawingml/2006/main">
             <a:pPr algn="ctr">
+              <a:buNone/>
               <a:defRPr sz="1650" b="1">
                 <a:solidFill>
                   <a:srgbClr val="FFFFFF"/>
@@ -17496,6 +17725,7 @@
           <a:lstStyle xmlns:a="http://schemas.openxmlformats.org/drawingml/2006/main"/>
           <a:p xmlns:a="http://schemas.openxmlformats.org/drawingml/2006/main">
             <a:pPr algn="ctr">
+              <a:buNone/>
               <a:defRPr sz="1500" b="1">
                 <a:solidFill>
                   <a:srgbClr val="0E1230"/>

</xml_diff>